<commit_message>
Presentation update, ml-service treshold fix
</commit_message>
<xml_diff>
--- a/Sveprisutno računarstvo - Projekat 2.pptx
+++ b/Sveprisutno računarstvo - Projekat 2.pptx
@@ -11,11 +11,11 @@
     <p:sldId id="256" r:id="rId2"/>
     <p:sldId id="259" r:id="rId3"/>
     <p:sldId id="260" r:id="rId4"/>
-    <p:sldId id="261" r:id="rId5"/>
-    <p:sldId id="257" r:id="rId6"/>
-    <p:sldId id="258" r:id="rId7"/>
-    <p:sldId id="262" r:id="rId8"/>
-    <p:sldId id="263" r:id="rId9"/>
+    <p:sldId id="265" r:id="rId5"/>
+    <p:sldId id="261" r:id="rId6"/>
+    <p:sldId id="266" r:id="rId7"/>
+    <p:sldId id="263" r:id="rId8"/>
+    <p:sldId id="267" r:id="rId9"/>
     <p:sldId id="264" r:id="rId10"/>
   </p:sldIdLst>
   <p:sldSz cx="12192000" cy="6858000"/>
@@ -205,7 +205,7 @@
           <a:p>
             <a:fld id="{A8C81B9A-2622-471D-AFDB-EC8C272BAC5C}" type="datetimeFigureOut">
               <a:rPr lang="en-US" smtClean="0"/>
-              <a:t>8/22/2026</a:t>
+              <a:t>8/29/2026</a:t>
             </a:fld>
             <a:endParaRPr lang="en-US"/>
           </a:p>
@@ -537,7 +537,7 @@
           <a:p>
             <a:fld id="{D23659A9-2044-4656-BCC8-7507CFDDA9E7}" type="slidenum">
               <a:rPr lang="en-US" smtClean="0"/>
-              <a:t>4</a:t>
+              <a:t>5</a:t>
             </a:fld>
             <a:endParaRPr lang="en-US"/>
           </a:p>
@@ -780,7 +780,7 @@
           <a:p>
             <a:fld id="{DB5A836A-52F5-4CAE-91B9-5EE85764AC96}" type="datetimeFigureOut">
               <a:rPr lang="en-US" smtClean="0"/>
-              <a:t>8/22/2026</a:t>
+              <a:t>8/29/2026</a:t>
             </a:fld>
             <a:endParaRPr lang="en-US"/>
           </a:p>
@@ -950,7 +950,7 @@
           <a:p>
             <a:fld id="{DB5A836A-52F5-4CAE-91B9-5EE85764AC96}" type="datetimeFigureOut">
               <a:rPr lang="en-US" smtClean="0"/>
-              <a:t>8/22/2026</a:t>
+              <a:t>8/29/2026</a:t>
             </a:fld>
             <a:endParaRPr lang="en-US"/>
           </a:p>
@@ -1130,7 +1130,7 @@
           <a:p>
             <a:fld id="{DB5A836A-52F5-4CAE-91B9-5EE85764AC96}" type="datetimeFigureOut">
               <a:rPr lang="en-US" smtClean="0"/>
-              <a:t>8/22/2026</a:t>
+              <a:t>8/29/2026</a:t>
             </a:fld>
             <a:endParaRPr lang="en-US"/>
           </a:p>
@@ -1300,7 +1300,7 @@
           <a:p>
             <a:fld id="{DB5A836A-52F5-4CAE-91B9-5EE85764AC96}" type="datetimeFigureOut">
               <a:rPr lang="en-US" smtClean="0"/>
-              <a:t>8/22/2026</a:t>
+              <a:t>8/29/2026</a:t>
             </a:fld>
             <a:endParaRPr lang="en-US"/>
           </a:p>
@@ -1558,7 +1558,7 @@
           <a:p>
             <a:fld id="{DB5A836A-52F5-4CAE-91B9-5EE85764AC96}" type="datetimeFigureOut">
               <a:rPr lang="en-US" smtClean="0"/>
-              <a:t>8/22/2026</a:t>
+              <a:t>8/29/2026</a:t>
             </a:fld>
             <a:endParaRPr lang="en-US"/>
           </a:p>
@@ -1846,7 +1846,7 @@
           <a:p>
             <a:fld id="{DB5A836A-52F5-4CAE-91B9-5EE85764AC96}" type="datetimeFigureOut">
               <a:rPr lang="en-US" smtClean="0"/>
-              <a:t>8/22/2026</a:t>
+              <a:t>8/29/2026</a:t>
             </a:fld>
             <a:endParaRPr lang="en-US"/>
           </a:p>
@@ -2288,7 +2288,7 @@
           <a:p>
             <a:fld id="{DB5A836A-52F5-4CAE-91B9-5EE85764AC96}" type="datetimeFigureOut">
               <a:rPr lang="en-US" smtClean="0"/>
-              <a:t>8/22/2026</a:t>
+              <a:t>8/29/2026</a:t>
             </a:fld>
             <a:endParaRPr lang="en-US"/>
           </a:p>
@@ -2406,7 +2406,7 @@
           <a:p>
             <a:fld id="{DB5A836A-52F5-4CAE-91B9-5EE85764AC96}" type="datetimeFigureOut">
               <a:rPr lang="en-US" smtClean="0"/>
-              <a:t>8/22/2026</a:t>
+              <a:t>8/29/2026</a:t>
             </a:fld>
             <a:endParaRPr lang="en-US"/>
           </a:p>
@@ -2501,7 +2501,7 @@
           <a:p>
             <a:fld id="{DB5A836A-52F5-4CAE-91B9-5EE85764AC96}" type="datetimeFigureOut">
               <a:rPr lang="en-US" smtClean="0"/>
-              <a:t>8/22/2026</a:t>
+              <a:t>8/29/2026</a:t>
             </a:fld>
             <a:endParaRPr lang="en-US"/>
           </a:p>
@@ -2789,7 +2789,7 @@
           <a:p>
             <a:fld id="{DB5A836A-52F5-4CAE-91B9-5EE85764AC96}" type="datetimeFigureOut">
               <a:rPr lang="en-US" smtClean="0"/>
-              <a:t>8/22/2026</a:t>
+              <a:t>8/29/2026</a:t>
             </a:fld>
             <a:endParaRPr lang="en-US"/>
           </a:p>
@@ -3062,7 +3062,7 @@
           <a:p>
             <a:fld id="{DB5A836A-52F5-4CAE-91B9-5EE85764AC96}" type="datetimeFigureOut">
               <a:rPr lang="en-US" smtClean="0"/>
-              <a:t>8/22/2026</a:t>
+              <a:t>8/29/2026</a:t>
             </a:fld>
             <a:endParaRPr lang="en-US"/>
           </a:p>
@@ -3359,7 +3359,7 @@
           <a:p>
             <a:fld id="{DB5A836A-52F5-4CAE-91B9-5EE85764AC96}" type="datetimeFigureOut">
               <a:rPr lang="en-US" smtClean="0"/>
-              <a:t>8/22/2026</a:t>
+              <a:t>8/29/2026</a:t>
             </a:fld>
             <a:endParaRPr lang="en-US"/>
           </a:p>
@@ -3997,7 +3997,9 @@
         </p:nvSpPr>
         <p:spPr/>
         <p:txBody>
-          <a:bodyPr/>
+          <a:bodyPr>
+            <a:normAutofit/>
+          </a:bodyPr>
           <a:lstStyle/>
           <a:p>
             <a:r>
@@ -4034,7 +4036,7 @@
             </a:r>
             <a:r>
               <a:rPr lang="en-US" dirty="0"/>
-              <a:t> </a:t>
+              <a:t> ML </a:t>
             </a:r>
             <a:r>
               <a:rPr lang="en-US" dirty="0" err="1"/>
@@ -4046,7 +4048,7 @@
             </a:r>
             <a:r>
               <a:rPr lang="en-US" dirty="0" err="1"/>
-              <a:t>osvetljenja</a:t>
+              <a:t>događaja</a:t>
             </a:r>
             <a:r>
               <a:rPr lang="en-US" dirty="0"/>
@@ -4058,7 +4060,15 @@
             </a:r>
             <a:r>
               <a:rPr lang="en-US" dirty="0"/>
-              <a:t> Arduino Nano 33 BLE Sense Lite</a:t>
+              <a:t> Arduino Nano 33 BLE Sense Lite </a:t>
+            </a:r>
+            <a:r>
+              <a:rPr lang="en-US" dirty="0" err="1"/>
+              <a:t>i</a:t>
+            </a:r>
+            <a:r>
+              <a:rPr lang="en-US" dirty="0"/>
+              <a:t> Raspberry Pie 4</a:t>
             </a:r>
           </a:p>
         </p:txBody>
@@ -4116,15 +4126,15 @@
           <a:p>
             <a:r>
               <a:rPr lang="en-US" dirty="0" err="1"/>
-              <a:t>Korišćeni</a:t>
-            </a:r>
-            <a:r>
-              <a:rPr lang="en-US" dirty="0"/>
-              <a:t> </a:t>
-            </a:r>
-            <a:r>
-              <a:rPr lang="en-US" dirty="0" err="1"/>
-              <a:t>hardver</a:t>
+              <a:t>Korišćene</a:t>
+            </a:r>
+            <a:r>
+              <a:rPr lang="en-US" dirty="0"/>
+              <a:t> </a:t>
+            </a:r>
+            <a:r>
+              <a:rPr lang="en-US" dirty="0" err="1"/>
+              <a:t>tehnologije</a:t>
             </a:r>
             <a:endParaRPr lang="en-US" dirty="0"/>
           </a:p>
@@ -4155,6 +4165,16 @@
               <a:buNone/>
             </a:pPr>
             <a:r>
+              <a:rPr lang="en-US" sz="3600" b="1" dirty="0" err="1"/>
+              <a:t>Hardver</a:t>
+            </a:r>
+            <a:br>
+              <a:rPr lang="en-US" sz="3600" b="1" dirty="0"/>
+            </a:br>
+            <a:br>
+              <a:rPr lang="en-US" b="1" dirty="0"/>
+            </a:br>
+            <a:r>
               <a:rPr lang="en-US" b="1" dirty="0"/>
               <a:t>Arduino Nano 33 BLE Sense Lite</a:t>
             </a:r>
@@ -4299,10 +4319,50 @@
               <a:rPr lang="en-US" dirty="0" err="1"/>
               <a:t>osvetljenja</a:t>
             </a:r>
-            <a:r>
-              <a:rPr lang="en-US" dirty="0"/>
-              <a:t> </a:t>
-            </a:r>
+            <a:endParaRPr lang="en-US" dirty="0"/>
+          </a:p>
+          <a:p>
+            <a:r>
+              <a:rPr lang="en-US" b="1" dirty="0"/>
+              <a:t>LSM9DS1 </a:t>
+            </a:r>
+            <a:r>
+              <a:rPr lang="en-US" b="1" dirty="0" err="1"/>
+              <a:t>senozr</a:t>
+            </a:r>
+            <a:r>
+              <a:rPr lang="en-US" b="1" dirty="0"/>
+              <a:t> </a:t>
+            </a:r>
+            <a:r>
+              <a:rPr lang="en-US" dirty="0"/>
+              <a:t>– za </a:t>
+            </a:r>
+            <a:r>
+              <a:rPr lang="en-US" dirty="0" err="1"/>
+              <a:t>prikupljanje</a:t>
+            </a:r>
+            <a:r>
+              <a:rPr lang="en-US" dirty="0"/>
+              <a:t> </a:t>
+            </a:r>
+            <a:r>
+              <a:rPr lang="en-US" dirty="0" err="1"/>
+              <a:t>podataka</a:t>
+            </a:r>
+            <a:r>
+              <a:rPr lang="en-US" dirty="0"/>
+              <a:t> za </a:t>
+            </a:r>
+            <a:r>
+              <a:rPr lang="en-US" dirty="0" err="1"/>
+              <a:t>akcelerometra</a:t>
+            </a:r>
+            <a:r>
+              <a:rPr lang="en-US" dirty="0"/>
+              <a:t> </a:t>
+            </a:r>
+            <a:endParaRPr lang="en-US" b="1" dirty="0"/>
           </a:p>
           <a:p>
             <a:r>
@@ -4311,19 +4371,44 @@
             </a:r>
             <a:r>
               <a:rPr lang="sr-Latn-RS" b="1" dirty="0"/>
-              <a:t> - </a:t>
+              <a:t> – </a:t>
             </a:r>
             <a:r>
               <a:rPr lang="en-US" dirty="0" err="1"/>
               <a:t>plava</a:t>
             </a:r>
             <a:r>
+              <a:rPr lang="en-US" dirty="0"/>
+              <a:t>, </a:t>
+            </a:r>
+            <a:r>
               <a:rPr lang="sr-Latn-RS" dirty="0"/>
-              <a:t> i crvena</a:t>
+              <a:t>crvena</a:t>
+            </a:r>
+            <a:r>
+              <a:rPr lang="en-US" dirty="0"/>
+              <a:t> i </a:t>
+            </a:r>
+            <a:r>
+              <a:rPr lang="en-US" dirty="0" err="1"/>
+              <a:t>zelena</a:t>
             </a:r>
             <a:r>
               <a:rPr lang="en-US" dirty="0"/>
               <a:t> LED</a:t>
+            </a:r>
+            <a:br>
+              <a:rPr lang="en-US" dirty="0"/>
+            </a:br>
+            <a:endParaRPr lang="en-US" dirty="0"/>
+          </a:p>
+          <a:p>
+            <a:pPr marL="0" indent="0">
+              <a:buNone/>
+            </a:pPr>
+            <a:r>
+              <a:rPr lang="en-US" b="1" dirty="0"/>
+              <a:t>Raspberry Pi 4</a:t>
             </a:r>
           </a:p>
         </p:txBody>
@@ -4342,6 +4427,244 @@
 </file>
 
 <file path=ppt/slides/slide4.xml><?xml version="1.0" encoding="utf-8"?>
+<p:sld xmlns:a="http://schemas.openxmlformats.org/drawingml/2006/main" xmlns:r="http://schemas.openxmlformats.org/officeDocument/2006/relationships" xmlns:p="http://schemas.openxmlformats.org/presentationml/2006/main">
+  <p:cSld>
+    <p:spTree>
+      <p:nvGrpSpPr>
+        <p:cNvPr id="1" name="">
+          <a:extLst>
+            <a:ext uri="{FF2B5EF4-FFF2-40B4-BE49-F238E27FC236}">
+              <a16:creationId xmlns:a16="http://schemas.microsoft.com/office/drawing/2014/main" id="{9BD5C279-6EBA-EBC2-4A1E-3A0ABA5C551A}"/>
+            </a:ext>
+          </a:extLst>
+        </p:cNvPr>
+        <p:cNvGrpSpPr/>
+        <p:nvPr/>
+      </p:nvGrpSpPr>
+      <p:grpSpPr>
+        <a:xfrm>
+          <a:off x="0" y="0"/>
+          <a:ext cx="0" cy="0"/>
+          <a:chOff x="0" y="0"/>
+          <a:chExt cx="0" cy="0"/>
+        </a:xfrm>
+      </p:grpSpPr>
+      <p:sp>
+        <p:nvSpPr>
+          <p:cNvPr id="2" name="Title 1">
+            <a:extLst>
+              <a:ext uri="{FF2B5EF4-FFF2-40B4-BE49-F238E27FC236}">
+                <a16:creationId xmlns:a16="http://schemas.microsoft.com/office/drawing/2014/main" id="{889E8D89-5B49-5439-FFBB-8ECF0E8E1DB1}"/>
+              </a:ext>
+            </a:extLst>
+          </p:cNvPr>
+          <p:cNvSpPr>
+            <a:spLocks noGrp="1"/>
+          </p:cNvSpPr>
+          <p:nvPr>
+            <p:ph type="title"/>
+          </p:nvPr>
+        </p:nvSpPr>
+        <p:spPr/>
+        <p:txBody>
+          <a:bodyPr/>
+          <a:lstStyle/>
+          <a:p>
+            <a:r>
+              <a:rPr lang="en-US" dirty="0" err="1"/>
+              <a:t>Korišćene</a:t>
+            </a:r>
+            <a:r>
+              <a:rPr lang="en-US" dirty="0"/>
+              <a:t> </a:t>
+            </a:r>
+            <a:r>
+              <a:rPr lang="en-US" dirty="0" err="1"/>
+              <a:t>tehnologije</a:t>
+            </a:r>
+            <a:endParaRPr lang="en-US" dirty="0"/>
+          </a:p>
+        </p:txBody>
+      </p:sp>
+      <p:sp>
+        <p:nvSpPr>
+          <p:cNvPr id="3" name="Content Placeholder 2">
+            <a:extLst>
+              <a:ext uri="{FF2B5EF4-FFF2-40B4-BE49-F238E27FC236}">
+                <a16:creationId xmlns:a16="http://schemas.microsoft.com/office/drawing/2014/main" id="{062DB333-373C-1319-9CB6-6BFC1F93FF0C}"/>
+              </a:ext>
+            </a:extLst>
+          </p:cNvPr>
+          <p:cNvSpPr>
+            <a:spLocks noGrp="1"/>
+          </p:cNvSpPr>
+          <p:nvPr>
+            <p:ph idx="1"/>
+          </p:nvPr>
+        </p:nvSpPr>
+        <p:spPr/>
+        <p:txBody>
+          <a:bodyPr/>
+          <a:lstStyle/>
+          <a:p>
+            <a:pPr marL="0" indent="0">
+              <a:buNone/>
+            </a:pPr>
+            <a:r>
+              <a:rPr lang="en-US" sz="3600" b="1" dirty="0" err="1"/>
+              <a:t>Softver</a:t>
+            </a:r>
+            <a:br>
+              <a:rPr lang="en-US" sz="3600" b="1" dirty="0"/>
+            </a:br>
+            <a:br>
+              <a:rPr lang="en-US" b="1" dirty="0"/>
+            </a:br>
+            <a:r>
+              <a:rPr lang="en-US" b="1" dirty="0"/>
+              <a:t>Python, Docker, Docker Compose</a:t>
+            </a:r>
+            <a:r>
+              <a:rPr lang="sr-Latn-RS" b="1" dirty="0"/>
+              <a:t>, </a:t>
+            </a:r>
+            <a:r>
+              <a:rPr lang="sr-Latn-RS" b="1" dirty="0" err="1"/>
+              <a:t>Mosquitto</a:t>
+            </a:r>
+            <a:r>
+              <a:rPr lang="sr-Latn-RS" b="1" dirty="0"/>
+              <a:t>, </a:t>
+            </a:r>
+            <a:r>
+              <a:rPr lang="sr-Latn-RS" b="1" dirty="0" err="1"/>
+              <a:t>TensorFlow</a:t>
+            </a:r>
+            <a:r>
+              <a:rPr lang="sr-Latn-RS" b="1" dirty="0"/>
+              <a:t> </a:t>
+            </a:r>
+            <a:r>
+              <a:rPr lang="sr-Latn-RS" b="1" dirty="0" err="1"/>
+              <a:t>Lite</a:t>
+            </a:r>
+            <a:r>
+              <a:rPr lang="sr-Latn-RS" b="1" dirty="0"/>
+              <a:t>, </a:t>
+            </a:r>
+            <a:r>
+              <a:rPr lang="sr-Latn-RS" b="1" dirty="0" err="1"/>
+              <a:t>InfluxDb</a:t>
+            </a:r>
+            <a:r>
+              <a:rPr lang="sr-Latn-RS" b="1" dirty="0"/>
+              <a:t>, </a:t>
+            </a:r>
+            <a:r>
+              <a:rPr lang="sr-Latn-RS" b="1" dirty="0" err="1"/>
+              <a:t>Grafana</a:t>
+            </a:r>
+            <a:endParaRPr lang="en-US" b="1" dirty="0"/>
+          </a:p>
+          <a:p>
+            <a:pPr marL="0" indent="0">
+              <a:buNone/>
+            </a:pPr>
+            <a:endParaRPr lang="en-US" b="1" dirty="0"/>
+          </a:p>
+          <a:p>
+            <a:pPr marL="0" indent="0">
+              <a:buNone/>
+            </a:pPr>
+            <a:endParaRPr lang="en-US" b="1" dirty="0"/>
+          </a:p>
+          <a:p>
+            <a:pPr marL="0" indent="0">
+              <a:buNone/>
+            </a:pPr>
+            <a:r>
+              <a:rPr lang="en-US" sz="3600" b="1" dirty="0" err="1"/>
+              <a:t>Komunikacija</a:t>
+            </a:r>
+            <a:endParaRPr lang="en-US" sz="3600" b="1" dirty="0"/>
+          </a:p>
+          <a:p>
+            <a:pPr marL="0" indent="0">
+              <a:buNone/>
+            </a:pPr>
+            <a:r>
+              <a:rPr lang="en-US" b="1" dirty="0" err="1"/>
+              <a:t>Serijska</a:t>
+            </a:r>
+            <a:r>
+              <a:rPr lang="en-US" b="1" dirty="0"/>
+              <a:t> </a:t>
+            </a:r>
+            <a:r>
+              <a:rPr lang="en-US" b="1" dirty="0" err="1"/>
+              <a:t>komunikacija</a:t>
+            </a:r>
+            <a:r>
+              <a:rPr lang="en-US" b="1" dirty="0"/>
+              <a:t> (USB) –</a:t>
+            </a:r>
+            <a:r>
+              <a:rPr lang="sr-Latn-RS" b="1" dirty="0"/>
+              <a:t> </a:t>
+            </a:r>
+            <a:r>
+              <a:rPr lang="en-US" dirty="0"/>
+              <a:t>Arduino </a:t>
+            </a:r>
+            <a:r>
+              <a:rPr lang="sr-Latn-RS" dirty="0"/>
+              <a:t>ka</a:t>
+            </a:r>
+            <a:r>
+              <a:rPr lang="en-US" dirty="0"/>
+              <a:t> </a:t>
+            </a:r>
+            <a:r>
+              <a:rPr lang="en-US" dirty="0" err="1"/>
+              <a:t>Rpi</a:t>
+            </a:r>
+            <a:br>
+              <a:rPr lang="sr-Latn-RS" dirty="0"/>
+            </a:br>
+            <a:r>
+              <a:rPr lang="sr-Latn-RS" b="1" dirty="0"/>
+              <a:t>MQTT protokol – </a:t>
+            </a:r>
+            <a:r>
+              <a:rPr lang="sr-Latn-RS" dirty="0" err="1"/>
+              <a:t>Rpi</a:t>
+            </a:r>
+            <a:r>
+              <a:rPr lang="sr-Latn-RS" dirty="0"/>
+              <a:t> ka </a:t>
+            </a:r>
+            <a:r>
+              <a:rPr lang="sr-Latn-RS" dirty="0" err="1"/>
+              <a:t>Arduino</a:t>
+            </a:r>
+            <a:endParaRPr lang="en-US" dirty="0"/>
+          </a:p>
+        </p:txBody>
+      </p:sp>
+    </p:spTree>
+    <p:extLst>
+      <p:ext uri="{BB962C8B-B14F-4D97-AF65-F5344CB8AC3E}">
+        <p14:creationId xmlns:p14="http://schemas.microsoft.com/office/powerpoint/2010/main" val="1308570711"/>
+      </p:ext>
+    </p:extLst>
+  </p:cSld>
+  <p:clrMapOvr>
+    <a:masterClrMapping/>
+  </p:clrMapOvr>
+</p:sld>
+</file>
+
+<file path=ppt/slides/slide5.xml><?xml version="1.0" encoding="utf-8"?>
 <p:sld xmlns:a="http://schemas.openxmlformats.org/drawingml/2006/main" xmlns:r="http://schemas.openxmlformats.org/officeDocument/2006/relationships" xmlns:p="http://schemas.openxmlformats.org/presentationml/2006/main">
   <p:cSld>
     <p:spTree>
@@ -4426,202 +4749,104 @@
               <a:buNone/>
             </a:pPr>
             <a:r>
+              <a:rPr lang="sr-Latn-RS" b="1" i="1" dirty="0"/>
+              <a:t>Zahtevi</a:t>
+            </a:r>
+            <a:endParaRPr lang="en-US" b="1" i="1" dirty="0"/>
+          </a:p>
+          <a:p>
+            <a:pPr lvl="0"/>
+            <a:r>
+              <a:rPr lang="en-US" dirty="0" err="1"/>
+              <a:t>Nadogradnja</a:t>
+            </a:r>
+            <a:r>
+              <a:rPr lang="en-US" dirty="0"/>
+              <a:t> </a:t>
+            </a:r>
+            <a:r>
+              <a:rPr lang="en-US" dirty="0" err="1"/>
+              <a:t>projekta</a:t>
+            </a:r>
+            <a:r>
+              <a:rPr lang="en-US" dirty="0"/>
+              <a:t> 1</a:t>
+            </a:r>
+          </a:p>
+          <a:p>
+            <a:pPr lvl="0"/>
+            <a:r>
+              <a:rPr lang="en-US" dirty="0" err="1"/>
+              <a:t>Treniranje</a:t>
+            </a:r>
+            <a:r>
+              <a:rPr lang="en-US" dirty="0"/>
+              <a:t> ML/Dl </a:t>
+            </a:r>
+            <a:r>
+              <a:rPr lang="en-US" dirty="0" err="1"/>
+              <a:t>modela</a:t>
+            </a:r>
+            <a:r>
+              <a:rPr lang="en-US" dirty="0"/>
+              <a:t> kori</a:t>
+            </a:r>
+            <a:r>
+              <a:rPr lang="sr-Latn-RS" dirty="0" err="1"/>
+              <a:t>šćenjem</a:t>
+            </a:r>
+            <a:r>
               <a:rPr lang="sr-Latn-RS" dirty="0"/>
-              <a:t>Zahtevi</a:t>
-            </a:r>
-            <a:r>
-              <a:rPr lang="en-US" dirty="0"/>
-              <a:t>:</a:t>
-            </a:r>
+              <a:t> </a:t>
+            </a:r>
+            <a:r>
+              <a:rPr lang="sr-Latn-RS" dirty="0" err="1"/>
+              <a:t>TensorFlow</a:t>
+            </a:r>
+            <a:r>
+              <a:rPr lang="sr-Latn-RS" dirty="0"/>
+              <a:t> </a:t>
+            </a:r>
+            <a:r>
+              <a:rPr lang="sr-Latn-RS" dirty="0" err="1"/>
+              <a:t>Lite</a:t>
+            </a:r>
+            <a:endParaRPr lang="sr-Latn-RS" dirty="0"/>
           </a:p>
           <a:p>
             <a:pPr lvl="0"/>
             <a:r>
-              <a:rPr lang="en-US" dirty="0" err="1"/>
-              <a:t>prepozn</a:t>
-            </a:r>
-            <a:r>
               <a:rPr lang="sr-Latn-RS" dirty="0"/>
-              <a:t>avan</a:t>
-            </a:r>
-            <a:r>
-              <a:rPr lang="en-US" dirty="0"/>
-              <a:t>je </a:t>
-            </a:r>
-            <a:r>
-              <a:rPr lang="en-US" dirty="0" err="1"/>
-              <a:t>glasovn</a:t>
-            </a:r>
-            <a:r>
-              <a:rPr lang="sr-Latn-RS" dirty="0"/>
-              <a:t>ih</a:t>
-            </a:r>
-            <a:r>
-              <a:rPr lang="en-US" dirty="0"/>
-              <a:t> </a:t>
-            </a:r>
-            <a:r>
-              <a:rPr lang="en-US" dirty="0" err="1"/>
-              <a:t>koman</a:t>
-            </a:r>
-            <a:r>
-              <a:rPr lang="sr-Latn-RS" dirty="0"/>
-              <a:t>di</a:t>
-            </a:r>
-            <a:r>
-              <a:rPr lang="en-US" dirty="0"/>
-              <a:t> </a:t>
-            </a:r>
-            <a:r>
-              <a:rPr lang="en-US" dirty="0" err="1"/>
-              <a:t>pomoću</a:t>
-            </a:r>
-            <a:r>
-              <a:rPr lang="en-US" dirty="0"/>
-              <a:t> Edge Impulse </a:t>
-            </a:r>
-            <a:r>
-              <a:rPr lang="en-US" dirty="0" err="1"/>
-              <a:t>modela</a:t>
-            </a:r>
-            <a:r>
-              <a:rPr lang="sr-Latn-RS" dirty="0"/>
-              <a:t>,</a:t>
-            </a:r>
-            <a:r>
-              <a:rPr lang="en-US" dirty="0"/>
-              <a:t> </a:t>
-            </a:r>
-          </a:p>
-          <a:p>
-            <a:pPr lvl="0"/>
-            <a:r>
-              <a:rPr lang="en-US" dirty="0"/>
-              <a:t>kori</a:t>
+              <a:t>Automatsko pokretanje </a:t>
             </a:r>
             <a:r>
               <a:rPr lang="sr-Latn-RS" dirty="0" err="1"/>
-              <a:t>šćenje</a:t>
-            </a:r>
-            <a:r>
-              <a:rPr lang="en-US" dirty="0"/>
-              <a:t> </a:t>
-            </a:r>
-            <a:r>
-              <a:rPr lang="en-US" dirty="0" err="1"/>
-              <a:t>ugrađen</a:t>
-            </a:r>
-            <a:r>
-              <a:rPr lang="sr-Latn-RS" dirty="0"/>
-              <a:t>ih</a:t>
-            </a:r>
-            <a:r>
-              <a:rPr lang="en-US" dirty="0"/>
-              <a:t> </a:t>
-            </a:r>
-            <a:r>
-              <a:rPr lang="en-US" dirty="0" err="1"/>
-              <a:t>senzor</a:t>
-            </a:r>
-            <a:r>
-              <a:rPr lang="sr-Latn-RS" dirty="0"/>
-              <a:t>a </a:t>
-            </a:r>
-            <a:r>
-              <a:rPr lang="en-US" dirty="0"/>
-              <a:t>Arduino Nano 33 BLE Sense Lite </a:t>
-            </a:r>
-            <a:r>
-              <a:rPr lang="en-US" dirty="0" err="1"/>
-              <a:t>ploče</a:t>
-            </a:r>
-            <a:r>
-              <a:rPr lang="sr-Latn-RS" dirty="0"/>
-              <a:t>,</a:t>
-            </a:r>
-            <a:endParaRPr lang="en-US" dirty="0"/>
-          </a:p>
-          <a:p>
-            <a:pPr lvl="0"/>
-            <a:r>
-              <a:rPr lang="en-US" dirty="0" err="1"/>
-              <a:t>reag</a:t>
-            </a:r>
-            <a:r>
-              <a:rPr lang="sr-Latn-RS" dirty="0" err="1"/>
-              <a:t>ovanje</a:t>
-            </a:r>
-            <a:r>
-              <a:rPr lang="en-US" dirty="0"/>
-              <a:t> </a:t>
-            </a:r>
-            <a:r>
-              <a:rPr lang="en-US" dirty="0" err="1"/>
-              <a:t>na</a:t>
-            </a:r>
-            <a:r>
-              <a:rPr lang="en-US" dirty="0"/>
-              <a:t> </a:t>
-            </a:r>
-            <a:r>
-              <a:rPr lang="en-US" dirty="0" err="1"/>
-              <a:t>događaje</a:t>
-            </a:r>
-            <a:r>
-              <a:rPr lang="en-US" dirty="0"/>
-              <a:t> </a:t>
-            </a:r>
-            <a:r>
-              <a:rPr lang="en-US" dirty="0" err="1"/>
-              <a:t>iz</a:t>
-            </a:r>
-            <a:r>
-              <a:rPr lang="en-US" dirty="0"/>
-              <a:t> </a:t>
-            </a:r>
-            <a:r>
-              <a:rPr lang="en-US" dirty="0" err="1"/>
-              <a:t>okruženja</a:t>
-            </a:r>
-            <a:r>
-              <a:rPr lang="en-US" dirty="0"/>
-              <a:t> </a:t>
-            </a:r>
-            <a:r>
-              <a:rPr lang="en-US" dirty="0" err="1"/>
-              <a:t>upravlja</a:t>
-            </a:r>
-            <a:r>
-              <a:rPr lang="sr-Latn-RS" dirty="0"/>
-              <a:t>njem </a:t>
-            </a:r>
-            <a:r>
-              <a:rPr lang="en-US" dirty="0" err="1"/>
-              <a:t>aktuator</a:t>
-            </a:r>
-            <a:r>
-              <a:rPr lang="sr-Latn-RS" dirty="0"/>
-              <a:t>a.</a:t>
-            </a:r>
+              <a:t>aktuatora</a:t>
+            </a:r>
+            <a:endParaRPr lang="sr-Latn-RS" dirty="0"/>
           </a:p>
           <a:p>
             <a:pPr marL="0" lvl="0" indent="0">
               <a:buNone/>
             </a:pPr>
-            <a:endParaRPr lang="sr-Latn-RS" dirty="0"/>
+            <a:endParaRPr lang="sr-Latn-RS" b="1" i="1" dirty="0"/>
           </a:p>
           <a:p>
             <a:pPr marL="0" lvl="0" indent="0">
               <a:buNone/>
             </a:pPr>
             <a:r>
-              <a:rPr lang="en-US" dirty="0" err="1"/>
+              <a:rPr lang="en-US" b="1" i="1" dirty="0" err="1"/>
               <a:t>Funkcionalnost</a:t>
             </a:r>
-            <a:endParaRPr lang="en-US" dirty="0"/>
-          </a:p>
-          <a:p>
-            <a:pPr lvl="0"/>
+            <a:r>
+              <a:rPr lang="sr-Latn-RS" b="1" i="1" dirty="0"/>
+              <a:t>i</a:t>
+            </a:r>
+            <a:endParaRPr lang="en-US" b="1" i="1" dirty="0"/>
+          </a:p>
+          <a:p>
+            <a:pPr lvl="0" algn="just"/>
             <a:r>
               <a:rPr lang="en-US" dirty="0" err="1"/>
               <a:t>Komanda</a:t>
@@ -4656,95 +4881,75 @@
             </a:r>
             <a:r>
               <a:rPr lang="sr-Latn-RS" dirty="0"/>
-              <a:t>očitavanje, aktivira se LED indikator i počinje da se o</a:t>
+              <a:t>očitavanje, aktivira se LED indikator i počinje o</a:t>
             </a:r>
             <a:r>
               <a:rPr lang="en-US" dirty="0" err="1"/>
               <a:t>čitava</a:t>
             </a:r>
             <a:r>
-              <a:rPr lang="en-US" dirty="0"/>
-              <a:t> </a:t>
-            </a:r>
-            <a:r>
-              <a:rPr lang="en-US" dirty="0" err="1"/>
-              <a:t>nivo</a:t>
-            </a:r>
-            <a:r>
-              <a:rPr lang="en-US" dirty="0"/>
-              <a:t> </a:t>
-            </a:r>
-            <a:r>
-              <a:rPr lang="en-US" dirty="0" err="1"/>
-              <a:t>osvetljenja</a:t>
+              <a:rPr lang="sr-Latn-RS" dirty="0"/>
+              <a:t>nje podataka sa </a:t>
+            </a:r>
+            <a:r>
+              <a:rPr lang="sr-Latn-RS" dirty="0" err="1"/>
+              <a:t>akcelerometra</a:t>
             </a:r>
             <a:r>
               <a:rPr lang="sr-Latn-RS" dirty="0"/>
               <a:t>.</a:t>
             </a:r>
+          </a:p>
+          <a:p>
+            <a:pPr lvl="0" algn="just"/>
+            <a:r>
+              <a:rPr lang="sr-Latn-RS" dirty="0"/>
+              <a:t>Podaci sa </a:t>
+            </a:r>
+            <a:r>
+              <a:rPr lang="sr-Latn-RS" dirty="0" err="1"/>
+              <a:t>akcelerometra</a:t>
+            </a:r>
+            <a:r>
+              <a:rPr lang="sr-Latn-RS" dirty="0"/>
+              <a:t> se šalju na </a:t>
+            </a:r>
+            <a:r>
+              <a:rPr lang="sr-Latn-RS" dirty="0" err="1"/>
+              <a:t>Rpi</a:t>
+            </a:r>
+            <a:r>
+              <a:rPr lang="sr-Latn-RS" dirty="0"/>
+              <a:t>, gde su pokrenuti servisi kroz </a:t>
+            </a:r>
+            <a:r>
+              <a:rPr lang="sr-Latn-RS" dirty="0" err="1"/>
+              <a:t>Docker</a:t>
+            </a:r>
+            <a:r>
+              <a:rPr lang="sr-Latn-RS" dirty="0"/>
+              <a:t> </a:t>
+            </a:r>
+            <a:r>
+              <a:rPr lang="sr-Latn-RS" dirty="0" err="1"/>
+              <a:t>compose</a:t>
+            </a:r>
+            <a:r>
+              <a:rPr lang="sr-Latn-RS" dirty="0"/>
+              <a:t>. Vrši se upis podataka u bazu, detekcija događaja i slanje komande za </a:t>
+            </a:r>
+            <a:r>
+              <a:rPr lang="sr-Latn-RS" dirty="0" err="1"/>
+              <a:t>aktuatore</a:t>
+            </a:r>
+            <a:r>
+              <a:rPr lang="sr-Latn-RS" dirty="0"/>
+              <a:t> po potrebi.</a:t>
+            </a:r>
             <a:endParaRPr lang="en-US" dirty="0"/>
           </a:p>
           <a:p>
-            <a:pPr lvl="0"/>
-            <a:r>
-              <a:rPr lang="en-US" dirty="0" err="1"/>
-              <a:t>Ukoliko</a:t>
-            </a:r>
-            <a:r>
-              <a:rPr lang="en-US" dirty="0"/>
-              <a:t> je </a:t>
-            </a:r>
-            <a:r>
-              <a:rPr lang="en-US" dirty="0" err="1"/>
-              <a:t>osvetljenje</a:t>
-            </a:r>
-            <a:r>
-              <a:rPr lang="en-US" dirty="0"/>
-              <a:t> </a:t>
-            </a:r>
-            <a:r>
-              <a:rPr lang="en-US" dirty="0" err="1"/>
-              <a:t>ve</a:t>
-            </a:r>
-            <a:r>
-              <a:rPr lang="sr-Latn-RS" dirty="0"/>
-              <a:t>će od </a:t>
-            </a:r>
-            <a:r>
-              <a:rPr lang="sr-Latn-RS" dirty="0" err="1"/>
-              <a:t>treshold</a:t>
-            </a:r>
-            <a:r>
-              <a:rPr lang="sr-Latn-RS" dirty="0"/>
-              <a:t> vrednosti</a:t>
-            </a:r>
-            <a:r>
-              <a:rPr lang="en-US" dirty="0"/>
-              <a:t> </a:t>
-            </a:r>
-            <a:r>
-              <a:rPr lang="en-US" dirty="0" err="1"/>
-              <a:t>aktivira</a:t>
-            </a:r>
-            <a:r>
-              <a:rPr lang="en-US" dirty="0"/>
-              <a:t> se LED </a:t>
-            </a:r>
-            <a:r>
-              <a:rPr lang="en-US" dirty="0" err="1"/>
-              <a:t>indikator</a:t>
-            </a:r>
-            <a:r>
-              <a:rPr lang="sr-Latn-RS" dirty="0"/>
-              <a:t>.</a:t>
-            </a:r>
-            <a:r>
-              <a:rPr lang="en-US" dirty="0"/>
-              <a:t> </a:t>
-            </a:r>
-          </a:p>
-          <a:p>
-            <a:pPr lvl="0"/>
+            <a:pPr lvl="0" algn="just"/>
             <a:r>
               <a:rPr lang="en-US" dirty="0" err="1"/>
               <a:t>Komanda</a:t>
@@ -4788,810 +4993,6 @@
     <p:extLst>
       <p:ext uri="{BB962C8B-B14F-4D97-AF65-F5344CB8AC3E}">
         <p14:creationId xmlns:p14="http://schemas.microsoft.com/office/powerpoint/2010/main" val="3183289694"/>
-      </p:ext>
-    </p:extLst>
-  </p:cSld>
-  <p:clrMapOvr>
-    <a:masterClrMapping/>
-  </p:clrMapOvr>
-</p:sld>
-</file>
-
-<file path=ppt/slides/slide5.xml><?xml version="1.0" encoding="utf-8"?>
-<p:sld xmlns:a="http://schemas.openxmlformats.org/drawingml/2006/main" xmlns:r="http://schemas.openxmlformats.org/officeDocument/2006/relationships" xmlns:p="http://schemas.openxmlformats.org/presentationml/2006/main">
-  <p:cSld>
-    <p:spTree>
-      <p:nvGrpSpPr>
-        <p:cNvPr id="1" name=""/>
-        <p:cNvGrpSpPr/>
-        <p:nvPr/>
-      </p:nvGrpSpPr>
-      <p:grpSpPr>
-        <a:xfrm>
-          <a:off x="0" y="0"/>
-          <a:ext cx="0" cy="0"/>
-          <a:chOff x="0" y="0"/>
-          <a:chExt cx="0" cy="0"/>
-        </a:xfrm>
-      </p:grpSpPr>
-      <p:sp>
-        <p:nvSpPr>
-          <p:cNvPr id="2" name="Title 1">
-            <a:extLst>
-              <a:ext uri="{FF2B5EF4-FFF2-40B4-BE49-F238E27FC236}">
-                <a16:creationId xmlns:a16="http://schemas.microsoft.com/office/drawing/2014/main" id="{B06D7AB2-6BD9-6EAC-CE2A-F60FCC919722}"/>
-              </a:ext>
-            </a:extLst>
-          </p:cNvPr>
-          <p:cNvSpPr>
-            <a:spLocks noGrp="1"/>
-          </p:cNvSpPr>
-          <p:nvPr>
-            <p:ph type="title"/>
-          </p:nvPr>
-        </p:nvSpPr>
-        <p:spPr/>
-        <p:txBody>
-          <a:bodyPr/>
-          <a:lstStyle/>
-          <a:p>
-            <a:r>
-              <a:rPr lang="en-US" dirty="0"/>
-              <a:t>Blok </a:t>
-            </a:r>
-            <a:r>
-              <a:rPr lang="en-US" dirty="0" err="1"/>
-              <a:t>dijagram</a:t>
-            </a:r>
-            <a:endParaRPr lang="en-US" dirty="0"/>
-          </a:p>
-        </p:txBody>
-      </p:sp>
-      <p:sp>
-        <p:nvSpPr>
-          <p:cNvPr id="3" name="Content Placeholder 2">
-            <a:extLst>
-              <a:ext uri="{FF2B5EF4-FFF2-40B4-BE49-F238E27FC236}">
-                <a16:creationId xmlns:a16="http://schemas.microsoft.com/office/drawing/2014/main" id="{52672D03-70E2-A4C4-C7FA-9586D12A9D48}"/>
-              </a:ext>
-            </a:extLst>
-          </p:cNvPr>
-          <p:cNvSpPr>
-            <a:spLocks noGrp="1"/>
-          </p:cNvSpPr>
-          <p:nvPr>
-            <p:ph idx="1"/>
-          </p:nvPr>
-        </p:nvSpPr>
-        <p:spPr/>
-        <p:txBody>
-          <a:bodyPr/>
-          <a:lstStyle/>
-          <a:p>
-            <a:endParaRPr lang="en-US" dirty="0"/>
-          </a:p>
-        </p:txBody>
-      </p:sp>
-      <p:sp>
-        <p:nvSpPr>
-          <p:cNvPr id="4" name="Rectangle 3">
-            <a:extLst>
-              <a:ext uri="{FF2B5EF4-FFF2-40B4-BE49-F238E27FC236}">
-                <a16:creationId xmlns:a16="http://schemas.microsoft.com/office/drawing/2014/main" id="{40F85D80-48E8-1FB3-C1DF-0FC1F86658F4}"/>
-              </a:ext>
-            </a:extLst>
-          </p:cNvPr>
-          <p:cNvSpPr/>
-          <p:nvPr/>
-        </p:nvSpPr>
-        <p:spPr>
-          <a:xfrm>
-            <a:off x="6705600" y="329269"/>
-            <a:ext cx="1504950" cy="615950"/>
-          </a:xfrm>
-          <a:prstGeom prst="rect">
-            <a:avLst/>
-          </a:prstGeom>
-        </p:spPr>
-        <p:style>
-          <a:lnRef idx="2">
-            <a:schemeClr val="accent1">
-              <a:shade val="15000"/>
-            </a:schemeClr>
-          </a:lnRef>
-          <a:fillRef idx="1">
-            <a:schemeClr val="accent1"/>
-          </a:fillRef>
-          <a:effectRef idx="0">
-            <a:schemeClr val="accent1"/>
-          </a:effectRef>
-          <a:fontRef idx="minor">
-            <a:schemeClr val="lt1"/>
-          </a:fontRef>
-        </p:style>
-        <p:txBody>
-          <a:bodyPr rtlCol="0" anchor="ctr"/>
-          <a:lstStyle/>
-          <a:p>
-            <a:pPr algn="ctr"/>
-            <a:r>
-              <a:rPr lang="sr-Latn-RS" dirty="0"/>
-              <a:t>Mikrofon</a:t>
-            </a:r>
-            <a:endParaRPr lang="en-US" dirty="0"/>
-          </a:p>
-        </p:txBody>
-      </p:sp>
-      <p:sp>
-        <p:nvSpPr>
-          <p:cNvPr id="6" name="Rectangle 5">
-            <a:extLst>
-              <a:ext uri="{FF2B5EF4-FFF2-40B4-BE49-F238E27FC236}">
-                <a16:creationId xmlns:a16="http://schemas.microsoft.com/office/drawing/2014/main" id="{0CF29BC1-D191-80FF-B1AF-3FCF4667E51E}"/>
-              </a:ext>
-            </a:extLst>
-          </p:cNvPr>
-          <p:cNvSpPr/>
-          <p:nvPr/>
-        </p:nvSpPr>
-        <p:spPr>
-          <a:xfrm>
-            <a:off x="6705600" y="1383369"/>
-            <a:ext cx="1504950" cy="615950"/>
-          </a:xfrm>
-          <a:prstGeom prst="rect">
-            <a:avLst/>
-          </a:prstGeom>
-        </p:spPr>
-        <p:style>
-          <a:lnRef idx="2">
-            <a:schemeClr val="accent1">
-              <a:shade val="15000"/>
-            </a:schemeClr>
-          </a:lnRef>
-          <a:fillRef idx="1">
-            <a:schemeClr val="accent1"/>
-          </a:fillRef>
-          <a:effectRef idx="0">
-            <a:schemeClr val="accent1"/>
-          </a:effectRef>
-          <a:fontRef idx="minor">
-            <a:schemeClr val="lt1"/>
-          </a:fontRef>
-        </p:style>
-        <p:txBody>
-          <a:bodyPr rtlCol="0" anchor="ctr"/>
-          <a:lstStyle/>
-          <a:p>
-            <a:pPr algn="ctr"/>
-            <a:r>
-              <a:rPr lang="sr-Latn-RS" dirty="0" err="1"/>
-              <a:t>Edge</a:t>
-            </a:r>
-            <a:r>
-              <a:rPr lang="sr-Latn-RS" dirty="0"/>
-              <a:t> Impulse model</a:t>
-            </a:r>
-            <a:endParaRPr lang="en-US" dirty="0"/>
-          </a:p>
-        </p:txBody>
-      </p:sp>
-      <p:sp>
-        <p:nvSpPr>
-          <p:cNvPr id="8" name="Rectangle 7">
-            <a:extLst>
-              <a:ext uri="{FF2B5EF4-FFF2-40B4-BE49-F238E27FC236}">
-                <a16:creationId xmlns:a16="http://schemas.microsoft.com/office/drawing/2014/main" id="{715C55F7-F972-1C18-8B71-5BE1207F181C}"/>
-              </a:ext>
-            </a:extLst>
-          </p:cNvPr>
-          <p:cNvSpPr/>
-          <p:nvPr/>
-        </p:nvSpPr>
-        <p:spPr>
-          <a:xfrm>
-            <a:off x="5200650" y="2565795"/>
-            <a:ext cx="1504950" cy="615950"/>
-          </a:xfrm>
-          <a:prstGeom prst="rect">
-            <a:avLst/>
-          </a:prstGeom>
-        </p:spPr>
-        <p:style>
-          <a:lnRef idx="2">
-            <a:schemeClr val="accent1">
-              <a:shade val="15000"/>
-            </a:schemeClr>
-          </a:lnRef>
-          <a:fillRef idx="1">
-            <a:schemeClr val="accent1"/>
-          </a:fillRef>
-          <a:effectRef idx="0">
-            <a:schemeClr val="accent1"/>
-          </a:effectRef>
-          <a:fontRef idx="minor">
-            <a:schemeClr val="lt1"/>
-          </a:fontRef>
-        </p:style>
-        <p:txBody>
-          <a:bodyPr rtlCol="0" anchor="ctr"/>
-          <a:lstStyle/>
-          <a:p>
-            <a:pPr algn="ctr"/>
-            <a:r>
-              <a:rPr lang="en-US" dirty="0"/>
-              <a:t>“</a:t>
-            </a:r>
-            <a:r>
-              <a:rPr lang="sr-Latn-RS" dirty="0"/>
-              <a:t>Let</a:t>
-            </a:r>
-            <a:r>
-              <a:rPr lang="en-US" dirty="0"/>
-              <a:t>`s </a:t>
-            </a:r>
-            <a:r>
-              <a:rPr lang="sr-Latn-RS" dirty="0"/>
-              <a:t>start</a:t>
-            </a:r>
-            <a:r>
-              <a:rPr lang="en-US" dirty="0"/>
-              <a:t>”</a:t>
-            </a:r>
-          </a:p>
-        </p:txBody>
-      </p:sp>
-      <p:sp>
-        <p:nvSpPr>
-          <p:cNvPr id="10" name="Rectangle 9">
-            <a:extLst>
-              <a:ext uri="{FF2B5EF4-FFF2-40B4-BE49-F238E27FC236}">
-                <a16:creationId xmlns:a16="http://schemas.microsoft.com/office/drawing/2014/main" id="{0740EB2A-E588-15B3-8AC2-319BC3DCC7CB}"/>
-              </a:ext>
-            </a:extLst>
-          </p:cNvPr>
-          <p:cNvSpPr/>
-          <p:nvPr/>
-        </p:nvSpPr>
-        <p:spPr>
-          <a:xfrm>
-            <a:off x="8210550" y="2565795"/>
-            <a:ext cx="1504950" cy="615950"/>
-          </a:xfrm>
-          <a:prstGeom prst="rect">
-            <a:avLst/>
-          </a:prstGeom>
-        </p:spPr>
-        <p:style>
-          <a:lnRef idx="2">
-            <a:schemeClr val="accent1">
-              <a:shade val="15000"/>
-            </a:schemeClr>
-          </a:lnRef>
-          <a:fillRef idx="1">
-            <a:schemeClr val="accent1"/>
-          </a:fillRef>
-          <a:effectRef idx="0">
-            <a:schemeClr val="accent1"/>
-          </a:effectRef>
-          <a:fontRef idx="minor">
-            <a:schemeClr val="lt1"/>
-          </a:fontRef>
-        </p:style>
-        <p:txBody>
-          <a:bodyPr rtlCol="0" anchor="ctr"/>
-          <a:lstStyle/>
-          <a:p>
-            <a:pPr algn="ctr"/>
-            <a:r>
-              <a:rPr lang="en-US" dirty="0"/>
-              <a:t>“</a:t>
-            </a:r>
-            <a:r>
-              <a:rPr lang="sr-Latn-RS" dirty="0" err="1"/>
-              <a:t>Finish</a:t>
-            </a:r>
-            <a:r>
-              <a:rPr lang="en-US" dirty="0"/>
-              <a:t>”</a:t>
-            </a:r>
-          </a:p>
-        </p:txBody>
-      </p:sp>
-      <p:sp>
-        <p:nvSpPr>
-          <p:cNvPr id="12" name="Rectangle 11">
-            <a:extLst>
-              <a:ext uri="{FF2B5EF4-FFF2-40B4-BE49-F238E27FC236}">
-                <a16:creationId xmlns:a16="http://schemas.microsoft.com/office/drawing/2014/main" id="{1E9D87D3-3068-31ED-344A-69CF291EE47A}"/>
-              </a:ext>
-            </a:extLst>
-          </p:cNvPr>
-          <p:cNvSpPr/>
-          <p:nvPr/>
-        </p:nvSpPr>
-        <p:spPr>
-          <a:xfrm>
-            <a:off x="5200650" y="3619895"/>
-            <a:ext cx="1504950" cy="615950"/>
-          </a:xfrm>
-          <a:prstGeom prst="rect">
-            <a:avLst/>
-          </a:prstGeom>
-        </p:spPr>
-        <p:style>
-          <a:lnRef idx="2">
-            <a:schemeClr val="accent1">
-              <a:shade val="15000"/>
-            </a:schemeClr>
-          </a:lnRef>
-          <a:fillRef idx="1">
-            <a:schemeClr val="accent1"/>
-          </a:fillRef>
-          <a:effectRef idx="0">
-            <a:schemeClr val="accent1"/>
-          </a:effectRef>
-          <a:fontRef idx="minor">
-            <a:schemeClr val="lt1"/>
-          </a:fontRef>
-        </p:style>
-        <p:txBody>
-          <a:bodyPr rtlCol="0" anchor="ctr"/>
-          <a:lstStyle/>
-          <a:p>
-            <a:pPr algn="ctr"/>
-            <a:r>
-              <a:rPr lang="sr-Latn-RS" dirty="0"/>
-              <a:t>Aktivacija sistema</a:t>
-            </a:r>
-            <a:endParaRPr lang="en-US" dirty="0"/>
-          </a:p>
-        </p:txBody>
-      </p:sp>
-      <p:sp>
-        <p:nvSpPr>
-          <p:cNvPr id="14" name="Rectangle 13">
-            <a:extLst>
-              <a:ext uri="{FF2B5EF4-FFF2-40B4-BE49-F238E27FC236}">
-                <a16:creationId xmlns:a16="http://schemas.microsoft.com/office/drawing/2014/main" id="{A57A9CEC-A07E-C9C1-D877-6608F4BF8A48}"/>
-              </a:ext>
-            </a:extLst>
-          </p:cNvPr>
-          <p:cNvSpPr/>
-          <p:nvPr/>
-        </p:nvSpPr>
-        <p:spPr>
-          <a:xfrm>
-            <a:off x="8210550" y="3619895"/>
-            <a:ext cx="1504950" cy="615950"/>
-          </a:xfrm>
-          <a:prstGeom prst="rect">
-            <a:avLst/>
-          </a:prstGeom>
-        </p:spPr>
-        <p:style>
-          <a:lnRef idx="2">
-            <a:schemeClr val="accent1">
-              <a:shade val="15000"/>
-            </a:schemeClr>
-          </a:lnRef>
-          <a:fillRef idx="1">
-            <a:schemeClr val="accent1"/>
-          </a:fillRef>
-          <a:effectRef idx="0">
-            <a:schemeClr val="accent1"/>
-          </a:effectRef>
-          <a:fontRef idx="minor">
-            <a:schemeClr val="lt1"/>
-          </a:fontRef>
-        </p:style>
-        <p:txBody>
-          <a:bodyPr rtlCol="0" anchor="ctr"/>
-          <a:lstStyle/>
-          <a:p>
-            <a:pPr algn="ctr"/>
-            <a:r>
-              <a:rPr lang="sr-Latn-RS" dirty="0"/>
-              <a:t>Zaustavljanje sistema</a:t>
-            </a:r>
-            <a:endParaRPr lang="en-US" dirty="0"/>
-          </a:p>
-        </p:txBody>
-      </p:sp>
-      <p:sp>
-        <p:nvSpPr>
-          <p:cNvPr id="16" name="Rectangle 15">
-            <a:extLst>
-              <a:ext uri="{FF2B5EF4-FFF2-40B4-BE49-F238E27FC236}">
-                <a16:creationId xmlns:a16="http://schemas.microsoft.com/office/drawing/2014/main" id="{7FE2F9FE-9C63-3B93-2545-CC0992D619BB}"/>
-              </a:ext>
-            </a:extLst>
-          </p:cNvPr>
-          <p:cNvSpPr/>
-          <p:nvPr/>
-        </p:nvSpPr>
-        <p:spPr>
-          <a:xfrm>
-            <a:off x="5200650" y="4802321"/>
-            <a:ext cx="1504950" cy="615950"/>
-          </a:xfrm>
-          <a:prstGeom prst="rect">
-            <a:avLst/>
-          </a:prstGeom>
-        </p:spPr>
-        <p:style>
-          <a:lnRef idx="2">
-            <a:schemeClr val="accent1">
-              <a:shade val="15000"/>
-            </a:schemeClr>
-          </a:lnRef>
-          <a:fillRef idx="1">
-            <a:schemeClr val="accent1"/>
-          </a:fillRef>
-          <a:effectRef idx="0">
-            <a:schemeClr val="accent1"/>
-          </a:effectRef>
-          <a:fontRef idx="minor">
-            <a:schemeClr val="lt1"/>
-          </a:fontRef>
-        </p:style>
-        <p:txBody>
-          <a:bodyPr rtlCol="0" anchor="ctr"/>
-          <a:lstStyle/>
-          <a:p>
-            <a:pPr algn="ctr"/>
-            <a:r>
-              <a:rPr lang="sr-Latn-RS" dirty="0"/>
-              <a:t>Detekcija osvetljenja</a:t>
-            </a:r>
-            <a:endParaRPr lang="en-US" dirty="0"/>
-          </a:p>
-        </p:txBody>
-      </p:sp>
-      <p:sp>
-        <p:nvSpPr>
-          <p:cNvPr id="18" name="Rectangle 17">
-            <a:extLst>
-              <a:ext uri="{FF2B5EF4-FFF2-40B4-BE49-F238E27FC236}">
-                <a16:creationId xmlns:a16="http://schemas.microsoft.com/office/drawing/2014/main" id="{520768CF-E141-0D6F-96FA-05F3091759AF}"/>
-              </a:ext>
-            </a:extLst>
-          </p:cNvPr>
-          <p:cNvSpPr/>
-          <p:nvPr/>
-        </p:nvSpPr>
-        <p:spPr>
-          <a:xfrm>
-            <a:off x="5200650" y="5865756"/>
-            <a:ext cx="1504950" cy="615950"/>
-          </a:xfrm>
-          <a:prstGeom prst="rect">
-            <a:avLst/>
-          </a:prstGeom>
-        </p:spPr>
-        <p:style>
-          <a:lnRef idx="2">
-            <a:schemeClr val="accent1">
-              <a:shade val="15000"/>
-            </a:schemeClr>
-          </a:lnRef>
-          <a:fillRef idx="1">
-            <a:schemeClr val="accent1"/>
-          </a:fillRef>
-          <a:effectRef idx="0">
-            <a:schemeClr val="accent1"/>
-          </a:effectRef>
-          <a:fontRef idx="minor">
-            <a:schemeClr val="lt1"/>
-          </a:fontRef>
-        </p:style>
-        <p:txBody>
-          <a:bodyPr rtlCol="0" anchor="ctr"/>
-          <a:lstStyle/>
-          <a:p>
-            <a:pPr algn="ctr"/>
-            <a:r>
-              <a:rPr lang="sr-Latn-RS" dirty="0"/>
-              <a:t>LED indikacija</a:t>
-            </a:r>
-            <a:endParaRPr lang="en-US" dirty="0"/>
-          </a:p>
-        </p:txBody>
-      </p:sp>
-      <p:cxnSp>
-        <p:nvCxnSpPr>
-          <p:cNvPr id="20" name="Straight Arrow Connector 19">
-            <a:extLst>
-              <a:ext uri="{FF2B5EF4-FFF2-40B4-BE49-F238E27FC236}">
-                <a16:creationId xmlns:a16="http://schemas.microsoft.com/office/drawing/2014/main" id="{921952A5-C75D-29EE-4F45-CCFCB9E6ABA2}"/>
-              </a:ext>
-            </a:extLst>
-          </p:cNvPr>
-          <p:cNvCxnSpPr>
-            <a:stCxn id="4" idx="2"/>
-            <a:endCxn id="6" idx="0"/>
-          </p:cNvCxnSpPr>
-          <p:nvPr/>
-        </p:nvCxnSpPr>
-        <p:spPr>
-          <a:xfrm>
-            <a:off x="7458075" y="945219"/>
-            <a:ext cx="0" cy="438150"/>
-          </a:xfrm>
-          <a:prstGeom prst="straightConnector1">
-            <a:avLst/>
-          </a:prstGeom>
-          <a:ln>
-            <a:tailEnd type="triangle"/>
-          </a:ln>
-        </p:spPr>
-        <p:style>
-          <a:lnRef idx="1">
-            <a:schemeClr val="accent1"/>
-          </a:lnRef>
-          <a:fillRef idx="0">
-            <a:schemeClr val="accent1"/>
-          </a:fillRef>
-          <a:effectRef idx="0">
-            <a:schemeClr val="accent1"/>
-          </a:effectRef>
-          <a:fontRef idx="minor">
-            <a:schemeClr val="tx1"/>
-          </a:fontRef>
-        </p:style>
-      </p:cxnSp>
-      <p:cxnSp>
-        <p:nvCxnSpPr>
-          <p:cNvPr id="22" name="Straight Arrow Connector 21">
-            <a:extLst>
-              <a:ext uri="{FF2B5EF4-FFF2-40B4-BE49-F238E27FC236}">
-                <a16:creationId xmlns:a16="http://schemas.microsoft.com/office/drawing/2014/main" id="{816502B2-4589-E4DD-A833-3EA2A1EC0E5A}"/>
-              </a:ext>
-            </a:extLst>
-          </p:cNvPr>
-          <p:cNvCxnSpPr>
-            <a:endCxn id="8" idx="0"/>
-          </p:cNvCxnSpPr>
-          <p:nvPr/>
-        </p:nvCxnSpPr>
-        <p:spPr>
-          <a:xfrm flipH="1">
-            <a:off x="5953125" y="1999319"/>
-            <a:ext cx="1504950" cy="566476"/>
-          </a:xfrm>
-          <a:prstGeom prst="straightConnector1">
-            <a:avLst/>
-          </a:prstGeom>
-          <a:ln>
-            <a:tailEnd type="triangle"/>
-          </a:ln>
-        </p:spPr>
-        <p:style>
-          <a:lnRef idx="1">
-            <a:schemeClr val="accent1"/>
-          </a:lnRef>
-          <a:fillRef idx="0">
-            <a:schemeClr val="accent1"/>
-          </a:fillRef>
-          <a:effectRef idx="0">
-            <a:schemeClr val="accent1"/>
-          </a:effectRef>
-          <a:fontRef idx="minor">
-            <a:schemeClr val="tx1"/>
-          </a:fontRef>
-        </p:style>
-      </p:cxnSp>
-      <p:cxnSp>
-        <p:nvCxnSpPr>
-          <p:cNvPr id="24" name="Straight Arrow Connector 23">
-            <a:extLst>
-              <a:ext uri="{FF2B5EF4-FFF2-40B4-BE49-F238E27FC236}">
-                <a16:creationId xmlns:a16="http://schemas.microsoft.com/office/drawing/2014/main" id="{02E5E747-83B9-F4DA-16B8-4C9280606852}"/>
-              </a:ext>
-            </a:extLst>
-          </p:cNvPr>
-          <p:cNvCxnSpPr>
-            <a:endCxn id="10" idx="0"/>
-          </p:cNvCxnSpPr>
-          <p:nvPr/>
-        </p:nvCxnSpPr>
-        <p:spPr>
-          <a:xfrm>
-            <a:off x="7458075" y="1999319"/>
-            <a:ext cx="1504950" cy="566476"/>
-          </a:xfrm>
-          <a:prstGeom prst="straightConnector1">
-            <a:avLst/>
-          </a:prstGeom>
-          <a:ln>
-            <a:tailEnd type="triangle"/>
-          </a:ln>
-        </p:spPr>
-        <p:style>
-          <a:lnRef idx="1">
-            <a:schemeClr val="accent1"/>
-          </a:lnRef>
-          <a:fillRef idx="0">
-            <a:schemeClr val="accent1"/>
-          </a:fillRef>
-          <a:effectRef idx="0">
-            <a:schemeClr val="accent1"/>
-          </a:effectRef>
-          <a:fontRef idx="minor">
-            <a:schemeClr val="tx1"/>
-          </a:fontRef>
-        </p:style>
-      </p:cxnSp>
-      <p:cxnSp>
-        <p:nvCxnSpPr>
-          <p:cNvPr id="26" name="Straight Arrow Connector 25">
-            <a:extLst>
-              <a:ext uri="{FF2B5EF4-FFF2-40B4-BE49-F238E27FC236}">
-                <a16:creationId xmlns:a16="http://schemas.microsoft.com/office/drawing/2014/main" id="{72B24273-96F6-5F33-02C0-EC94AC611C3A}"/>
-              </a:ext>
-            </a:extLst>
-          </p:cNvPr>
-          <p:cNvCxnSpPr>
-            <a:stCxn id="10" idx="2"/>
-            <a:endCxn id="14" idx="0"/>
-          </p:cNvCxnSpPr>
-          <p:nvPr/>
-        </p:nvCxnSpPr>
-        <p:spPr>
-          <a:xfrm>
-            <a:off x="8963025" y="3181745"/>
-            <a:ext cx="0" cy="438150"/>
-          </a:xfrm>
-          <a:prstGeom prst="straightConnector1">
-            <a:avLst/>
-          </a:prstGeom>
-          <a:ln>
-            <a:tailEnd type="triangle"/>
-          </a:ln>
-        </p:spPr>
-        <p:style>
-          <a:lnRef idx="1">
-            <a:schemeClr val="accent1"/>
-          </a:lnRef>
-          <a:fillRef idx="0">
-            <a:schemeClr val="accent1"/>
-          </a:fillRef>
-          <a:effectRef idx="0">
-            <a:schemeClr val="accent1"/>
-          </a:effectRef>
-          <a:fontRef idx="minor">
-            <a:schemeClr val="tx1"/>
-          </a:fontRef>
-        </p:style>
-      </p:cxnSp>
-      <p:cxnSp>
-        <p:nvCxnSpPr>
-          <p:cNvPr id="28" name="Straight Arrow Connector 27">
-            <a:extLst>
-              <a:ext uri="{FF2B5EF4-FFF2-40B4-BE49-F238E27FC236}">
-                <a16:creationId xmlns:a16="http://schemas.microsoft.com/office/drawing/2014/main" id="{E871E39D-5A45-02BB-DED0-7A124555DBFE}"/>
-              </a:ext>
-            </a:extLst>
-          </p:cNvPr>
-          <p:cNvCxnSpPr>
-            <a:endCxn id="12" idx="0"/>
-          </p:cNvCxnSpPr>
-          <p:nvPr/>
-        </p:nvCxnSpPr>
-        <p:spPr>
-          <a:xfrm>
-            <a:off x="5953125" y="3181745"/>
-            <a:ext cx="0" cy="438150"/>
-          </a:xfrm>
-          <a:prstGeom prst="straightConnector1">
-            <a:avLst/>
-          </a:prstGeom>
-          <a:ln>
-            <a:tailEnd type="triangle"/>
-          </a:ln>
-        </p:spPr>
-        <p:style>
-          <a:lnRef idx="1">
-            <a:schemeClr val="accent1"/>
-          </a:lnRef>
-          <a:fillRef idx="0">
-            <a:schemeClr val="accent1"/>
-          </a:fillRef>
-          <a:effectRef idx="0">
-            <a:schemeClr val="accent1"/>
-          </a:effectRef>
-          <a:fontRef idx="minor">
-            <a:schemeClr val="tx1"/>
-          </a:fontRef>
-        </p:style>
-      </p:cxnSp>
-      <p:cxnSp>
-        <p:nvCxnSpPr>
-          <p:cNvPr id="30" name="Straight Arrow Connector 29">
-            <a:extLst>
-              <a:ext uri="{FF2B5EF4-FFF2-40B4-BE49-F238E27FC236}">
-                <a16:creationId xmlns:a16="http://schemas.microsoft.com/office/drawing/2014/main" id="{7E865ED0-01B5-E8D8-83EC-5B689D0ABACA}"/>
-              </a:ext>
-            </a:extLst>
-          </p:cNvPr>
-          <p:cNvCxnSpPr>
-            <a:endCxn id="16" idx="0"/>
-          </p:cNvCxnSpPr>
-          <p:nvPr/>
-        </p:nvCxnSpPr>
-        <p:spPr>
-          <a:xfrm>
-            <a:off x="5953125" y="4235845"/>
-            <a:ext cx="0" cy="566476"/>
-          </a:xfrm>
-          <a:prstGeom prst="straightConnector1">
-            <a:avLst/>
-          </a:prstGeom>
-          <a:ln>
-            <a:tailEnd type="triangle"/>
-          </a:ln>
-        </p:spPr>
-        <p:style>
-          <a:lnRef idx="1">
-            <a:schemeClr val="accent1"/>
-          </a:lnRef>
-          <a:fillRef idx="0">
-            <a:schemeClr val="accent1"/>
-          </a:fillRef>
-          <a:effectRef idx="0">
-            <a:schemeClr val="accent1"/>
-          </a:effectRef>
-          <a:fontRef idx="minor">
-            <a:schemeClr val="tx1"/>
-          </a:fontRef>
-        </p:style>
-      </p:cxnSp>
-      <p:cxnSp>
-        <p:nvCxnSpPr>
-          <p:cNvPr id="32" name="Straight Arrow Connector 31">
-            <a:extLst>
-              <a:ext uri="{FF2B5EF4-FFF2-40B4-BE49-F238E27FC236}">
-                <a16:creationId xmlns:a16="http://schemas.microsoft.com/office/drawing/2014/main" id="{D19595E5-6E45-2AC9-892F-466291E1A248}"/>
-              </a:ext>
-            </a:extLst>
-          </p:cNvPr>
-          <p:cNvCxnSpPr>
-            <a:stCxn id="16" idx="2"/>
-            <a:endCxn id="18" idx="0"/>
-          </p:cNvCxnSpPr>
-          <p:nvPr/>
-        </p:nvCxnSpPr>
-        <p:spPr>
-          <a:xfrm>
-            <a:off x="5953125" y="5418271"/>
-            <a:ext cx="0" cy="447485"/>
-          </a:xfrm>
-          <a:prstGeom prst="straightConnector1">
-            <a:avLst/>
-          </a:prstGeom>
-          <a:ln>
-            <a:tailEnd type="triangle"/>
-          </a:ln>
-        </p:spPr>
-        <p:style>
-          <a:lnRef idx="1">
-            <a:schemeClr val="accent1"/>
-          </a:lnRef>
-          <a:fillRef idx="0">
-            <a:schemeClr val="accent1"/>
-          </a:fillRef>
-          <a:effectRef idx="0">
-            <a:schemeClr val="accent1"/>
-          </a:effectRef>
-          <a:fontRef idx="minor">
-            <a:schemeClr val="tx1"/>
-          </a:fontRef>
-        </p:style>
-      </p:cxnSp>
-    </p:spTree>
-    <p:extLst>
-      <p:ext uri="{BB962C8B-B14F-4D97-AF65-F5344CB8AC3E}">
-        <p14:creationId xmlns:p14="http://schemas.microsoft.com/office/powerpoint/2010/main" val="1725129141"/>
       </p:ext>
     </p:extLst>
   </p:cSld>
@@ -5606,7 +5007,13 @@
   <p:cSld>
     <p:spTree>
       <p:nvGrpSpPr>
-        <p:cNvPr id="1" name=""/>
+        <p:cNvPr id="1" name="">
+          <a:extLst>
+            <a:ext uri="{FF2B5EF4-FFF2-40B4-BE49-F238E27FC236}">
+              <a16:creationId xmlns:a16="http://schemas.microsoft.com/office/drawing/2014/main" id="{2223B32F-CED6-9A72-769A-0FC2C50EE1B0}"/>
+            </a:ext>
+          </a:extLst>
+        </p:cNvPr>
         <p:cNvGrpSpPr/>
         <p:nvPr/>
       </p:nvGrpSpPr>
@@ -5623,7 +5030,7 @@
           <p:cNvPr id="2" name="Title 1">
             <a:extLst>
               <a:ext uri="{FF2B5EF4-FFF2-40B4-BE49-F238E27FC236}">
-                <a16:creationId xmlns:a16="http://schemas.microsoft.com/office/drawing/2014/main" id="{09AE3652-C73C-B59E-0622-2A416964CD7F}"/>
+                <a16:creationId xmlns:a16="http://schemas.microsoft.com/office/drawing/2014/main" id="{38CCCC84-BBBE-0C80-D8BE-F0C4A1F98AE0}"/>
               </a:ext>
             </a:extLst>
           </p:cNvPr>
@@ -5640,9 +5047,10 @@
           <a:lstStyle/>
           <a:p>
             <a:r>
-              <a:rPr lang="en-US" dirty="0"/>
-              <a:t>Edge Impulse model</a:t>
-            </a:r>
+              <a:rPr lang="sr-Latn-RS" dirty="0"/>
+              <a:t>Prikupljanje podataka</a:t>
+            </a:r>
+            <a:endParaRPr lang="en-US" dirty="0"/>
           </a:p>
         </p:txBody>
       </p:sp>
@@ -5651,7 +5059,7 @@
           <p:cNvPr id="3" name="Content Placeholder 2">
             <a:extLst>
               <a:ext uri="{FF2B5EF4-FFF2-40B4-BE49-F238E27FC236}">
-                <a16:creationId xmlns:a16="http://schemas.microsoft.com/office/drawing/2014/main" id="{CCA1A07F-0FE3-4D28-3E1A-80AEF4BF3241}"/>
+                <a16:creationId xmlns:a16="http://schemas.microsoft.com/office/drawing/2014/main" id="{577B7D8D-2DBF-ACA0-3B9B-1D978D7F91B0}"/>
               </a:ext>
             </a:extLst>
           </p:cNvPr>
@@ -5667,164 +5075,283 @@
           <a:bodyPr/>
           <a:lstStyle/>
           <a:p>
-            <a:pPr marL="0" indent="0">
-              <a:buNone/>
-            </a:pPr>
-            <a:r>
-              <a:rPr lang="en-US" dirty="0"/>
-              <a:t>Model je </a:t>
-            </a:r>
-            <a:r>
-              <a:rPr lang="en-US" dirty="0" err="1"/>
-              <a:t>treniran</a:t>
-            </a:r>
-            <a:r>
-              <a:rPr lang="en-US" dirty="0"/>
-              <a:t> u Edge Impulse </a:t>
-            </a:r>
-            <a:r>
-              <a:rPr lang="en-US" dirty="0" err="1"/>
-              <a:t>platformi</a:t>
+            <a:pPr algn="just"/>
+            <a:r>
+              <a:rPr lang="sr-Latn-RS" dirty="0"/>
+              <a:t>Nakon startovanja sistema komandom </a:t>
+            </a:r>
+            <a:r>
+              <a:rPr lang="en-US" b="1" dirty="0"/>
+              <a:t>"Let`s</a:t>
+            </a:r>
+            <a:r>
+              <a:rPr lang="sr-Latn-RS" b="1" dirty="0"/>
+              <a:t> </a:t>
+            </a:r>
+            <a:r>
+              <a:rPr lang="en-US" b="1" dirty="0"/>
+              <a:t>start"</a:t>
+            </a:r>
+            <a:r>
+              <a:rPr lang="en-US" dirty="0"/>
+              <a:t> </a:t>
+            </a:r>
+            <a:r>
+              <a:rPr lang="sr-Latn-RS" dirty="0"/>
+              <a:t> prikupljaju se podaci sa a</a:t>
+            </a:r>
+            <a:r>
+              <a:rPr lang="en-US" dirty="0" err="1"/>
+              <a:t>kceleromet</a:t>
+            </a:r>
+            <a:r>
+              <a:rPr lang="sr-Latn-RS" dirty="0" err="1"/>
+              <a:t>ra</a:t>
+            </a:r>
+            <a:r>
+              <a:rPr lang="sr-Latn-RS" dirty="0"/>
+              <a:t> sa frekvencijom uzrokovanja 20 </a:t>
+            </a:r>
+            <a:r>
+              <a:rPr lang="sr-Latn-RS" dirty="0" err="1"/>
+              <a:t>Hz</a:t>
+            </a:r>
+            <a:r>
+              <a:rPr lang="sr-Latn-RS" dirty="0"/>
+              <a:t>:</a:t>
+            </a:r>
+          </a:p>
+          <a:p>
+            <a:pPr lvl="1" algn="just"/>
+            <a:r>
+              <a:rPr lang="en-US" dirty="0"/>
+              <a:t>X </a:t>
+            </a:r>
+            <a:r>
+              <a:rPr lang="en-US" dirty="0" err="1"/>
+              <a:t>osa</a:t>
+            </a:r>
+            <a:r>
+              <a:rPr lang="en-US" dirty="0"/>
+              <a:t> </a:t>
+            </a:r>
+          </a:p>
+          <a:p>
+            <a:pPr lvl="1" algn="just"/>
+            <a:r>
+              <a:rPr lang="en-US" dirty="0"/>
+              <a:t>Y </a:t>
+            </a:r>
+            <a:r>
+              <a:rPr lang="en-US" dirty="0" err="1"/>
+              <a:t>osa</a:t>
+            </a:r>
+            <a:r>
+              <a:rPr lang="en-US" dirty="0"/>
+              <a:t> </a:t>
+            </a:r>
+          </a:p>
+          <a:p>
+            <a:pPr lvl="1" algn="just"/>
+            <a:r>
+              <a:rPr lang="en-US" dirty="0"/>
+              <a:t>Z </a:t>
+            </a:r>
+            <a:r>
+              <a:rPr lang="en-US" dirty="0" err="1"/>
+              <a:t>osa</a:t>
+            </a:r>
+            <a:r>
+              <a:rPr lang="en-US" dirty="0"/>
+              <a:t> </a:t>
+            </a:r>
+            <a:endParaRPr lang="sr-Latn-RS" dirty="0"/>
+          </a:p>
+          <a:p>
+            <a:pPr algn="just"/>
+            <a:r>
+              <a:rPr lang="sr-Latn-RS" dirty="0"/>
+              <a:t>Servis </a:t>
+            </a:r>
+            <a:r>
+              <a:rPr lang="sr-Latn-RS" b="1" i="1" dirty="0" err="1"/>
+              <a:t>read_from_arduino</a:t>
+            </a:r>
+            <a:r>
+              <a:rPr lang="sr-Latn-RS" b="1" i="1" dirty="0"/>
+              <a:t> </a:t>
+            </a:r>
+            <a:r>
+              <a:rPr lang="sr-Latn-RS" dirty="0"/>
+              <a:t>je pomoćni </a:t>
+            </a:r>
+            <a:r>
+              <a:rPr lang="sr-Latn-RS" dirty="0" err="1"/>
+              <a:t>Python</a:t>
+            </a:r>
+            <a:r>
+              <a:rPr lang="sr-Latn-RS" dirty="0"/>
+              <a:t> servis koji kontinuirano osluškuje </a:t>
+            </a:r>
+            <a:r>
+              <a:rPr lang="sr-Latn-RS" dirty="0" err="1"/>
+              <a:t>serijksi</a:t>
+            </a:r>
+            <a:r>
+              <a:rPr lang="sr-Latn-RS" dirty="0"/>
+              <a:t> port korišćenjem </a:t>
+            </a:r>
+            <a:r>
+              <a:rPr lang="sr-Latn-RS" dirty="0" err="1"/>
+              <a:t>PySerial</a:t>
+            </a:r>
+            <a:r>
+              <a:rPr lang="sr-Latn-RS" dirty="0"/>
+              <a:t> biblioteke. Vrši parsiranje podataka i šalje izdvojene</a:t>
+            </a:r>
+            <a:r>
+              <a:rPr lang="en-US" dirty="0"/>
+              <a:t> </a:t>
+            </a:r>
+            <a:r>
+              <a:rPr lang="en-US" dirty="0" err="1"/>
+              <a:t>vrednosti</a:t>
+            </a:r>
+            <a:r>
+              <a:rPr lang="en-US" dirty="0"/>
+              <a:t> </a:t>
+            </a:r>
+            <a:r>
+              <a:rPr lang="en-US" dirty="0" err="1"/>
+              <a:t>akcelerometra</a:t>
+            </a:r>
+            <a:r>
+              <a:rPr lang="en-US" dirty="0"/>
+              <a:t> po </a:t>
+            </a:r>
+            <a:r>
+              <a:rPr lang="en-US" dirty="0" err="1"/>
+              <a:t>osama</a:t>
+            </a:r>
+            <a:r>
+              <a:rPr lang="en-US" dirty="0"/>
+              <a:t> </a:t>
+            </a:r>
+            <a:r>
+              <a:rPr lang="en-US" b="1" dirty="0"/>
+              <a:t>X</a:t>
+            </a:r>
+            <a:r>
+              <a:rPr lang="en-US" dirty="0"/>
+              <a:t>, </a:t>
+            </a:r>
+            <a:r>
+              <a:rPr lang="en-US" b="1" dirty="0"/>
+              <a:t>Y</a:t>
+            </a:r>
+            <a:r>
+              <a:rPr lang="en-US" dirty="0"/>
+              <a:t>, </a:t>
+            </a:r>
+            <a:r>
+              <a:rPr lang="en-US" b="1" dirty="0"/>
+              <a:t>Z</a:t>
+            </a:r>
+            <a:r>
+              <a:rPr lang="en-US" dirty="0"/>
+              <a:t>, </a:t>
+            </a:r>
+            <a:r>
+              <a:rPr lang="en-US" dirty="0" err="1"/>
+              <a:t>kao</a:t>
+            </a:r>
+            <a:r>
+              <a:rPr lang="en-US" dirty="0"/>
+              <a:t> </a:t>
+            </a:r>
+            <a:r>
+              <a:rPr lang="en-US" dirty="0" err="1"/>
+              <a:t>i</a:t>
+            </a:r>
+            <a:r>
+              <a:rPr lang="en-US" dirty="0"/>
+              <a:t> </a:t>
+            </a:r>
+            <a:r>
+              <a:rPr lang="en-US" dirty="0" err="1"/>
+              <a:t>ukupn</a:t>
+            </a:r>
+            <a:r>
+              <a:rPr lang="sr-Latn-RS" dirty="0"/>
+              <a:t>u</a:t>
+            </a:r>
+            <a:r>
+              <a:rPr lang="en-US" dirty="0"/>
+              <a:t> </a:t>
+            </a:r>
+            <a:r>
+              <a:rPr lang="en-US" dirty="0" err="1"/>
+              <a:t>magnitud</a:t>
+            </a:r>
+            <a:r>
+              <a:rPr lang="sr-Latn-RS" dirty="0"/>
+              <a:t>u</a:t>
+            </a:r>
+            <a:r>
+              <a:rPr lang="en-US" dirty="0"/>
+              <a:t> </a:t>
+            </a:r>
+            <a:r>
+              <a:rPr lang="en-US" dirty="0" err="1"/>
+              <a:t>ubrzanja</a:t>
+            </a:r>
+            <a:r>
+              <a:rPr lang="en-US" dirty="0"/>
+              <a:t> (</a:t>
+            </a:r>
+            <a:r>
+              <a:rPr lang="en-US" b="1" dirty="0"/>
+              <a:t>Total</a:t>
+            </a:r>
+            <a:r>
+              <a:rPr lang="en-US" dirty="0"/>
+              <a:t>)</a:t>
+            </a:r>
+            <a:r>
+              <a:rPr lang="sr-Latn-RS" dirty="0"/>
+              <a:t> na MQTT </a:t>
+            </a:r>
+            <a:r>
+              <a:rPr lang="sr-Latn-RS" dirty="0" err="1"/>
+              <a:t>topic</a:t>
+            </a:r>
+            <a:r>
+              <a:rPr lang="sr-Latn-RS" dirty="0"/>
+              <a:t> </a:t>
+            </a:r>
+            <a:r>
+              <a:rPr lang="sr-Latn-RS" b="1" i="1" dirty="0" err="1"/>
+              <a:t>sensors</a:t>
+            </a:r>
+            <a:r>
+              <a:rPr lang="sr-Latn-RS" b="1" i="1" dirty="0"/>
+              <a:t>/</a:t>
+            </a:r>
+            <a:r>
+              <a:rPr lang="sr-Latn-RS" b="1" i="1" dirty="0" err="1"/>
+              <a:t>arduino</a:t>
             </a:r>
             <a:r>
               <a:rPr lang="en-US" dirty="0"/>
               <a:t>.</a:t>
             </a:r>
-          </a:p>
-          <a:p>
-            <a:pPr marL="0" indent="0">
-              <a:buNone/>
-            </a:pPr>
-            <a:r>
-              <a:rPr lang="en-US" b="1" dirty="0"/>
-              <a:t>Klase</a:t>
-            </a:r>
-          </a:p>
-          <a:p>
-            <a:pPr lvl="0"/>
-            <a:r>
-              <a:rPr lang="en-US" dirty="0" err="1"/>
-              <a:t>Lets_start</a:t>
-            </a:r>
-            <a:r>
-              <a:rPr lang="en-US" dirty="0"/>
-              <a:t> </a:t>
-            </a:r>
-          </a:p>
-          <a:p>
-            <a:pPr lvl="0"/>
-            <a:r>
-              <a:rPr lang="en-US" dirty="0"/>
-              <a:t>Finish </a:t>
-            </a:r>
-          </a:p>
-          <a:p>
-            <a:pPr lvl="0"/>
-            <a:r>
-              <a:rPr lang="en-US" dirty="0"/>
-              <a:t>Noise </a:t>
-            </a:r>
-          </a:p>
-          <a:p>
-            <a:pPr marL="0" indent="0">
-              <a:buNone/>
-            </a:pPr>
-            <a:r>
-              <a:rPr lang="en-US" b="1" dirty="0" err="1"/>
-              <a:t>Proces</a:t>
-            </a:r>
-            <a:endParaRPr lang="en-US" b="1" dirty="0"/>
-          </a:p>
-          <a:p>
-            <a:pPr lvl="0"/>
-            <a:r>
-              <a:rPr lang="en-US" dirty="0" err="1"/>
-              <a:t>Snimanje</a:t>
-            </a:r>
-            <a:r>
-              <a:rPr lang="en-US" dirty="0"/>
-              <a:t> audio </a:t>
-            </a:r>
-            <a:r>
-              <a:rPr lang="en-US" dirty="0" err="1"/>
-              <a:t>uzoraka</a:t>
-            </a:r>
-            <a:r>
-              <a:rPr lang="en-US" dirty="0"/>
-              <a:t> </a:t>
-            </a:r>
-          </a:p>
-          <a:p>
-            <a:pPr lvl="0"/>
-            <a:r>
-              <a:rPr lang="en-US" dirty="0" err="1"/>
-              <a:t>Ekstrakcija</a:t>
-            </a:r>
-            <a:r>
-              <a:rPr lang="en-US" dirty="0"/>
-              <a:t> MFCC </a:t>
-            </a:r>
-            <a:r>
-              <a:rPr lang="en-US" dirty="0" err="1"/>
-              <a:t>karakteristika</a:t>
-            </a:r>
-            <a:r>
-              <a:rPr lang="en-US" dirty="0"/>
-              <a:t> </a:t>
-            </a:r>
-          </a:p>
-          <a:p>
-            <a:pPr lvl="0"/>
-            <a:r>
-              <a:rPr lang="en-US" dirty="0" err="1"/>
-              <a:t>Treniranje</a:t>
-            </a:r>
-            <a:r>
-              <a:rPr lang="en-US" dirty="0"/>
-              <a:t> </a:t>
-            </a:r>
-            <a:r>
-              <a:rPr lang="en-US" dirty="0" err="1"/>
-              <a:t>klasifikacionog</a:t>
-            </a:r>
-            <a:r>
-              <a:rPr lang="en-US" dirty="0"/>
-              <a:t> </a:t>
-            </a:r>
-            <a:r>
-              <a:rPr lang="en-US" dirty="0" err="1"/>
-              <a:t>modela</a:t>
-            </a:r>
-            <a:r>
-              <a:rPr lang="en-US" dirty="0"/>
-              <a:t> </a:t>
-            </a:r>
-          </a:p>
-          <a:p>
-            <a:pPr lvl="0"/>
-            <a:r>
-              <a:rPr lang="en-US" dirty="0" err="1"/>
-              <a:t>Generisanje</a:t>
-            </a:r>
-            <a:r>
-              <a:rPr lang="en-US" dirty="0"/>
-              <a:t> Arduino </a:t>
-            </a:r>
-            <a:r>
-              <a:rPr lang="en-US" dirty="0" err="1"/>
-              <a:t>biblioteke</a:t>
-            </a:r>
-            <a:endParaRPr lang="en-US" dirty="0"/>
-          </a:p>
-          <a:p>
-            <a:endParaRPr lang="en-US" dirty="0"/>
           </a:p>
         </p:txBody>
       </p:sp>
     </p:spTree>
     <p:extLst>
       <p:ext uri="{BB962C8B-B14F-4D97-AF65-F5344CB8AC3E}">
-        <p14:creationId xmlns:p14="http://schemas.microsoft.com/office/powerpoint/2010/main" val="387543634"/>
+        <p14:creationId xmlns:p14="http://schemas.microsoft.com/office/powerpoint/2010/main" val="1817219891"/>
       </p:ext>
     </p:extLst>
   </p:cSld>
@@ -5856,7 +5383,7 @@
           <p:cNvPr id="2" name="Title 1">
             <a:extLst>
               <a:ext uri="{FF2B5EF4-FFF2-40B4-BE49-F238E27FC236}">
-                <a16:creationId xmlns:a16="http://schemas.microsoft.com/office/drawing/2014/main" id="{5CFE8C28-0CCF-98B1-6CF8-D6F34E0C48A6}"/>
+                <a16:creationId xmlns:a16="http://schemas.microsoft.com/office/drawing/2014/main" id="{34643757-4B98-313B-6635-1523A5974920}"/>
               </a:ext>
             </a:extLst>
           </p:cNvPr>
@@ -5873,12 +5400,8 @@
           <a:lstStyle/>
           <a:p>
             <a:r>
-              <a:rPr lang="en-US" dirty="0"/>
-              <a:t>Tok </a:t>
-            </a:r>
-            <a:r>
-              <a:rPr lang="en-US" dirty="0" err="1"/>
-              <a:t>izvršavanja</a:t>
+              <a:rPr lang="sr-Latn-RS" dirty="0"/>
+              <a:t>Skladištenje podataka</a:t>
             </a:r>
             <a:endParaRPr lang="en-US" dirty="0"/>
           </a:p>
@@ -5889,7 +5412,7 @@
           <p:cNvPr id="3" name="Content Placeholder 2">
             <a:extLst>
               <a:ext uri="{FF2B5EF4-FFF2-40B4-BE49-F238E27FC236}">
-                <a16:creationId xmlns:a16="http://schemas.microsoft.com/office/drawing/2014/main" id="{D36ED36D-86EB-D622-AC00-B6233068B835}"/>
+                <a16:creationId xmlns:a16="http://schemas.microsoft.com/office/drawing/2014/main" id="{E05BD1B0-0EAF-4A7E-47A5-DB54851320C6}"/>
               </a:ext>
             </a:extLst>
           </p:cNvPr>
@@ -5900,136 +5423,190 @@
             <p:ph idx="1"/>
           </p:nvPr>
         </p:nvSpPr>
-        <p:spPr/>
+        <p:spPr>
+          <a:xfrm>
+            <a:off x="3734096" y="-535322"/>
+            <a:ext cx="7315200" cy="5120640"/>
+          </a:xfrm>
+        </p:spPr>
         <p:txBody>
           <a:bodyPr/>
           <a:lstStyle/>
           <a:p>
-            <a:pPr marL="0" indent="0">
-              <a:buNone/>
-            </a:pPr>
-            <a:r>
-              <a:rPr lang="en-US" b="1" dirty="0"/>
-              <a:t>Arduino C++ </a:t>
-            </a:r>
-            <a:r>
-              <a:rPr lang="en-US" b="1" dirty="0" err="1"/>
-              <a:t>aplikacija</a:t>
-            </a:r>
-            <a:r>
-              <a:rPr lang="en-US" b="1" dirty="0"/>
-              <a:t>:</a:t>
-            </a:r>
-          </a:p>
-          <a:p>
-            <a:pPr lvl="0"/>
-            <a:r>
-              <a:rPr lang="en-US" dirty="0" err="1"/>
-              <a:t>Inicijalizuje</a:t>
-            </a:r>
-            <a:r>
-              <a:rPr lang="en-US" dirty="0"/>
-              <a:t> </a:t>
-            </a:r>
-            <a:r>
-              <a:rPr lang="en-US" dirty="0" err="1"/>
-              <a:t>mikrofon</a:t>
-            </a:r>
-            <a:r>
-              <a:rPr lang="en-US" dirty="0"/>
-              <a:t> </a:t>
-            </a:r>
-          </a:p>
-          <a:p>
-            <a:pPr lvl="0"/>
-            <a:r>
-              <a:rPr lang="en-US" dirty="0" err="1"/>
-              <a:t>Inicijalizuje</a:t>
-            </a:r>
-            <a:r>
-              <a:rPr lang="en-US" dirty="0"/>
-              <a:t> APDS9960 </a:t>
-            </a:r>
-            <a:r>
-              <a:rPr lang="en-US" dirty="0" err="1"/>
-              <a:t>senzor</a:t>
-            </a:r>
-            <a:r>
-              <a:rPr lang="en-US" dirty="0"/>
-              <a:t> </a:t>
-            </a:r>
-          </a:p>
-          <a:p>
-            <a:pPr lvl="0"/>
-            <a:r>
-              <a:rPr lang="en-US" dirty="0" err="1"/>
-              <a:t>Učitava</a:t>
-            </a:r>
-            <a:r>
-              <a:rPr lang="en-US" dirty="0"/>
-              <a:t> Edge Impulse model </a:t>
-            </a:r>
-          </a:p>
-          <a:p>
-            <a:pPr lvl="0"/>
-            <a:r>
-              <a:rPr lang="en-US" dirty="0" err="1"/>
-              <a:t>Kontinuirano</a:t>
-            </a:r>
-            <a:r>
-              <a:rPr lang="en-US" dirty="0"/>
-              <a:t> </a:t>
-            </a:r>
-            <a:r>
-              <a:rPr lang="en-US" dirty="0" err="1"/>
-              <a:t>sluša</a:t>
-            </a:r>
-            <a:r>
-              <a:rPr lang="en-US" dirty="0"/>
-              <a:t> audio signal </a:t>
-            </a:r>
-          </a:p>
-          <a:p>
-            <a:pPr lvl="0"/>
-            <a:r>
-              <a:rPr lang="en-US" dirty="0" err="1"/>
-              <a:t>Vrši</a:t>
-            </a:r>
-            <a:r>
-              <a:rPr lang="en-US" dirty="0"/>
-              <a:t> </a:t>
-            </a:r>
-            <a:r>
-              <a:rPr lang="en-US" dirty="0" err="1"/>
-              <a:t>klasifikaciju</a:t>
-            </a:r>
-            <a:r>
-              <a:rPr lang="en-US" dirty="0"/>
-              <a:t> </a:t>
-            </a:r>
-            <a:r>
-              <a:rPr lang="en-US" dirty="0" err="1"/>
-              <a:t>glasovnih</a:t>
-            </a:r>
-            <a:r>
-              <a:rPr lang="en-US" dirty="0"/>
-              <a:t> </a:t>
-            </a:r>
-            <a:r>
-              <a:rPr lang="en-US" dirty="0" err="1"/>
-              <a:t>komandi</a:t>
-            </a:r>
+            <a:pPr algn="just"/>
+            <a:r>
+              <a:rPr lang="en-US" dirty="0"/>
+              <a:t>Servis </a:t>
+            </a:r>
+            <a:r>
+              <a:rPr lang="en-US" b="1" i="1" dirty="0" err="1"/>
+              <a:t>mqtt</a:t>
+            </a:r>
+            <a:r>
+              <a:rPr lang="en-US" b="1" i="1" dirty="0"/>
+              <a:t>-to-influx</a:t>
+            </a:r>
+            <a:r>
+              <a:rPr lang="en-US" dirty="0"/>
+              <a:t> je </a:t>
+            </a:r>
+            <a:r>
+              <a:rPr lang="en-US" dirty="0" err="1"/>
+              <a:t>zadužen</a:t>
+            </a:r>
+            <a:r>
+              <a:rPr lang="en-US" dirty="0"/>
+              <a:t> za </a:t>
+            </a:r>
+            <a:r>
+              <a:rPr lang="en-US" dirty="0" err="1"/>
+              <a:t>skladištenje</a:t>
+            </a:r>
+            <a:r>
+              <a:rPr lang="en-US" dirty="0"/>
+              <a:t> </a:t>
+            </a:r>
+            <a:r>
+              <a:rPr lang="en-US" dirty="0" err="1"/>
+              <a:t>senzorskih</a:t>
+            </a:r>
+            <a:r>
+              <a:rPr lang="en-US" dirty="0"/>
+              <a:t> </a:t>
+            </a:r>
+            <a:r>
+              <a:rPr lang="en-US" dirty="0" err="1"/>
+              <a:t>podataka</a:t>
+            </a:r>
+            <a:r>
+              <a:rPr lang="en-US" dirty="0"/>
+              <a:t> u </a:t>
+            </a:r>
+            <a:r>
+              <a:rPr lang="en-US" dirty="0" err="1"/>
+              <a:t>InfluxDB</a:t>
+            </a:r>
+            <a:r>
+              <a:rPr lang="en-US" dirty="0"/>
+              <a:t>.</a:t>
+            </a:r>
+            <a:r>
+              <a:rPr lang="sr-Latn-RS" dirty="0"/>
+              <a:t> P</a:t>
+            </a:r>
+            <a:r>
+              <a:rPr lang="en-US" dirty="0" err="1"/>
+              <a:t>retplaćen</a:t>
+            </a:r>
+            <a:r>
+              <a:rPr lang="en-US" dirty="0"/>
+              <a:t> </a:t>
+            </a:r>
+            <a:r>
+              <a:rPr lang="sr-Latn-RS" dirty="0"/>
+              <a:t>je </a:t>
+            </a:r>
+            <a:r>
+              <a:rPr lang="en-US" dirty="0" err="1"/>
+              <a:t>na</a:t>
+            </a:r>
+            <a:r>
+              <a:rPr lang="sr-Latn-RS" dirty="0"/>
+              <a:t> </a:t>
+            </a:r>
+            <a:r>
+              <a:rPr lang="sr-Latn-RS" b="1" i="1" dirty="0" err="1"/>
+              <a:t>sensors</a:t>
+            </a:r>
+            <a:r>
+              <a:rPr lang="sr-Latn-RS" b="1" i="1" dirty="0"/>
+              <a:t>/</a:t>
+            </a:r>
+            <a:r>
+              <a:rPr lang="sr-Latn-RS" b="1" i="1" dirty="0" err="1"/>
+              <a:t>arduino</a:t>
+            </a:r>
+            <a:r>
+              <a:rPr lang="sr-Latn-RS" b="1" i="1" dirty="0"/>
+              <a:t> </a:t>
+            </a:r>
+            <a:r>
+              <a:rPr lang="en-US" dirty="0"/>
+              <a:t>MQTT topic</a:t>
+            </a:r>
+            <a:r>
+              <a:rPr lang="sr-Latn-RS" dirty="0"/>
+              <a:t>.</a:t>
+            </a:r>
+            <a:r>
+              <a:rPr lang="en-US" dirty="0"/>
+              <a:t> </a:t>
+            </a:r>
+            <a:endParaRPr lang="sr-Latn-RS" dirty="0"/>
+          </a:p>
+          <a:p>
+            <a:pPr algn="just"/>
+            <a:r>
+              <a:rPr lang="sr-Latn-RS" dirty="0"/>
+              <a:t>Podaci iz </a:t>
+            </a:r>
+            <a:r>
+              <a:rPr lang="sr-Latn-RS" dirty="0" err="1"/>
+              <a:t>InfluxDb</a:t>
+            </a:r>
+            <a:r>
+              <a:rPr lang="sr-Latn-RS" dirty="0"/>
+              <a:t> se vizualizuju u </a:t>
+            </a:r>
+            <a:r>
+              <a:rPr lang="sr-Latn-RS" dirty="0" err="1"/>
+              <a:t>Grafani</a:t>
+            </a:r>
+            <a:r>
+              <a:rPr lang="sr-Latn-RS" dirty="0"/>
+              <a:t>.</a:t>
+            </a:r>
+          </a:p>
+          <a:p>
+            <a:pPr algn="just"/>
             <a:endParaRPr lang="en-US" dirty="0"/>
           </a:p>
-          <a:p>
-            <a:endParaRPr lang="en-US" dirty="0"/>
-          </a:p>
-        </p:txBody>
-      </p:sp>
+        </p:txBody>
+      </p:sp>
+      <p:pic>
+        <p:nvPicPr>
+          <p:cNvPr id="5" name="Picture 4">
+            <a:extLst>
+              <a:ext uri="{FF2B5EF4-FFF2-40B4-BE49-F238E27FC236}">
+                <a16:creationId xmlns:a16="http://schemas.microsoft.com/office/drawing/2014/main" id="{49FE0B0A-C797-87BD-EA8C-5CACB06CD88B}"/>
+              </a:ext>
+            </a:extLst>
+          </p:cNvPr>
+          <p:cNvPicPr>
+            <a:picLocks noChangeAspect="1"/>
+          </p:cNvPicPr>
+          <p:nvPr/>
+        </p:nvPicPr>
+        <p:blipFill>
+          <a:blip r:embed="rId2"/>
+          <a:stretch>
+            <a:fillRect/>
+          </a:stretch>
+        </p:blipFill>
+        <p:spPr>
+          <a:xfrm>
+            <a:off x="5249156" y="2998966"/>
+            <a:ext cx="3972046" cy="3172703"/>
+          </a:xfrm>
+          <a:prstGeom prst="rect">
+            <a:avLst/>
+          </a:prstGeom>
+        </p:spPr>
+      </p:pic>
     </p:spTree>
     <p:extLst>
       <p:ext uri="{BB962C8B-B14F-4D97-AF65-F5344CB8AC3E}">
-        <p14:creationId xmlns:p14="http://schemas.microsoft.com/office/powerpoint/2010/main" val="1063456335"/>
+        <p14:creationId xmlns:p14="http://schemas.microsoft.com/office/powerpoint/2010/main" val="2433535033"/>
       </p:ext>
     </p:extLst>
   </p:cSld>
@@ -6044,7 +5621,13 @@
   <p:cSld>
     <p:spTree>
       <p:nvGrpSpPr>
-        <p:cNvPr id="1" name=""/>
+        <p:cNvPr id="1" name="">
+          <a:extLst>
+            <a:ext uri="{FF2B5EF4-FFF2-40B4-BE49-F238E27FC236}">
+              <a16:creationId xmlns:a16="http://schemas.microsoft.com/office/drawing/2014/main" id="{6D5A109F-0AF6-45BF-03CC-B43714CB0971}"/>
+            </a:ext>
+          </a:extLst>
+        </p:cNvPr>
         <p:cNvGrpSpPr/>
         <p:nvPr/>
       </p:nvGrpSpPr>
@@ -6061,7 +5644,7 @@
           <p:cNvPr id="2" name="Title 1">
             <a:extLst>
               <a:ext uri="{FF2B5EF4-FFF2-40B4-BE49-F238E27FC236}">
-                <a16:creationId xmlns:a16="http://schemas.microsoft.com/office/drawing/2014/main" id="{34643757-4B98-313B-6635-1523A5974920}"/>
+                <a16:creationId xmlns:a16="http://schemas.microsoft.com/office/drawing/2014/main" id="{FD380A51-78F7-FFC9-B00D-388FC3BFDD7C}"/>
               </a:ext>
             </a:extLst>
           </p:cNvPr>
@@ -6078,24 +5661,20 @@
           <a:lstStyle/>
           <a:p>
             <a:r>
-              <a:rPr lang="en-US" dirty="0" err="1"/>
-              <a:t>Detekcija</a:t>
-            </a:r>
-            <a:r>
-              <a:rPr lang="en-US" dirty="0"/>
-              <a:t> </a:t>
-            </a:r>
-            <a:r>
-              <a:rPr lang="en-US" dirty="0" err="1"/>
-              <a:t>glasovnih</a:t>
-            </a:r>
-            <a:r>
-              <a:rPr lang="en-US" dirty="0"/>
-              <a:t> </a:t>
-            </a:r>
-            <a:r>
-              <a:rPr lang="en-US" dirty="0" err="1"/>
-              <a:t>komandi</a:t>
+              <a:rPr lang="sr-Latn-RS" dirty="0"/>
+              <a:t>T</a:t>
+            </a:r>
+            <a:r>
+              <a:rPr lang="en-US" dirty="0" err="1"/>
+              <a:t>reniranje</a:t>
+            </a:r>
+            <a:r>
+              <a:rPr lang="en-US" dirty="0"/>
+              <a:t> </a:t>
+            </a:r>
+            <a:r>
+              <a:rPr lang="en-US" dirty="0" err="1"/>
+              <a:t>modela</a:t>
             </a:r>
             <a:endParaRPr lang="en-US" dirty="0"/>
           </a:p>
@@ -6106,7 +5685,7 @@
           <p:cNvPr id="3" name="Content Placeholder 2">
             <a:extLst>
               <a:ext uri="{FF2B5EF4-FFF2-40B4-BE49-F238E27FC236}">
-                <a16:creationId xmlns:a16="http://schemas.microsoft.com/office/drawing/2014/main" id="{E05BD1B0-0EAF-4A7E-47A5-DB54851320C6}"/>
+                <a16:creationId xmlns:a16="http://schemas.microsoft.com/office/drawing/2014/main" id="{3026D7CC-F34F-A816-E727-D8C6779B0655}"/>
               </a:ext>
             </a:extLst>
           </p:cNvPr>
@@ -6122,133 +5701,280 @@
           <a:bodyPr/>
           <a:lstStyle/>
           <a:p>
-            <a:r>
-              <a:rPr lang="en-US" dirty="0" err="1"/>
-              <a:t>Postoje</a:t>
-            </a:r>
-            <a:r>
-              <a:rPr lang="en-US" dirty="0"/>
-              <a:t> 2 audio </a:t>
-            </a:r>
-            <a:r>
-              <a:rPr lang="en-US" dirty="0" err="1"/>
-              <a:t>bafera</a:t>
-            </a:r>
-            <a:r>
-              <a:rPr lang="en-US" dirty="0"/>
-              <a:t> </a:t>
-            </a:r>
-            <a:r>
-              <a:rPr lang="en-US" dirty="0" err="1"/>
-              <a:t>kako</a:t>
-            </a:r>
-            <a:r>
-              <a:rPr lang="en-US" dirty="0"/>
-              <a:t> bi se </a:t>
-            </a:r>
-            <a:r>
-              <a:rPr lang="en-US" dirty="0" err="1"/>
-              <a:t>jedan</a:t>
-            </a:r>
-            <a:r>
-              <a:rPr lang="en-US" dirty="0"/>
-              <a:t> </a:t>
-            </a:r>
-            <a:r>
-              <a:rPr lang="en-US" dirty="0" err="1"/>
-              <a:t>punio</a:t>
-            </a:r>
-            <a:r>
-              <a:rPr lang="en-US" dirty="0"/>
-              <a:t> </a:t>
-            </a:r>
-            <a:r>
-              <a:rPr lang="en-US" dirty="0" err="1"/>
-              <a:t>novim</a:t>
-            </a:r>
-            <a:r>
-              <a:rPr lang="en-US" dirty="0"/>
-              <a:t> </a:t>
-            </a:r>
-            <a:r>
-              <a:rPr lang="en-US" dirty="0" err="1"/>
-              <a:t>podacima</a:t>
-            </a:r>
-            <a:r>
-              <a:rPr lang="en-US" dirty="0"/>
-              <a:t> </a:t>
-            </a:r>
-            <a:r>
-              <a:rPr lang="en-US" dirty="0" err="1"/>
-              <a:t>sa</a:t>
-            </a:r>
-            <a:r>
-              <a:rPr lang="en-US" dirty="0"/>
-              <a:t> </a:t>
-            </a:r>
-            <a:r>
-              <a:rPr lang="en-US" dirty="0" err="1"/>
-              <a:t>mikrofona</a:t>
-            </a:r>
-            <a:r>
-              <a:rPr lang="en-US" dirty="0"/>
-              <a:t>, </a:t>
-            </a:r>
-            <a:r>
-              <a:rPr lang="en-US" dirty="0" err="1"/>
-              <a:t>dok</a:t>
-            </a:r>
-            <a:r>
-              <a:rPr lang="en-US" dirty="0"/>
-              <a:t> se </a:t>
-            </a:r>
-            <a:r>
-              <a:rPr lang="en-US" dirty="0" err="1"/>
-              <a:t>drugi</a:t>
-            </a:r>
-            <a:r>
-              <a:rPr lang="en-US" dirty="0"/>
-              <a:t> </a:t>
-            </a:r>
-            <a:r>
-              <a:rPr lang="en-US" dirty="0" err="1"/>
-              <a:t>koristi</a:t>
-            </a:r>
-            <a:r>
-              <a:rPr lang="en-US" dirty="0"/>
-              <a:t> za ML </a:t>
-            </a:r>
-            <a:r>
-              <a:rPr lang="en-US" dirty="0" err="1"/>
-              <a:t>obradu</a:t>
+            <a:pPr algn="just"/>
+            <a:r>
+              <a:rPr lang="en-US" dirty="0" err="1"/>
+              <a:t>Prikuplj</a:t>
+            </a:r>
+            <a:r>
+              <a:rPr lang="sr-Latn-RS" dirty="0" err="1"/>
+              <a:t>eni</a:t>
+            </a:r>
+            <a:r>
+              <a:rPr lang="en-US" dirty="0"/>
+              <a:t> s</a:t>
+            </a:r>
+            <a:r>
+              <a:rPr lang="sr-Latn-RS" dirty="0"/>
+              <a:t>u</a:t>
+            </a:r>
+            <a:r>
+              <a:rPr lang="en-US" dirty="0"/>
+              <a:t> </a:t>
+            </a:r>
+            <a:r>
+              <a:rPr lang="en-US" dirty="0" err="1"/>
+              <a:t>podaci</a:t>
+            </a:r>
+            <a:r>
+              <a:rPr lang="en-US" dirty="0"/>
+              <a:t> </a:t>
+            </a:r>
+            <a:r>
+              <a:rPr lang="en-US" dirty="0" err="1"/>
+              <a:t>akcelerometra</a:t>
+            </a:r>
+            <a:r>
+              <a:rPr lang="en-US" dirty="0"/>
+              <a:t> za </a:t>
+            </a:r>
+            <a:r>
+              <a:rPr lang="en-US" dirty="0" err="1"/>
+              <a:t>različite</a:t>
+            </a:r>
+            <a:r>
+              <a:rPr lang="en-US" dirty="0"/>
+              <a:t> </a:t>
+            </a:r>
+            <a:r>
+              <a:rPr lang="en-US" dirty="0" err="1"/>
+              <a:t>klase</a:t>
+            </a:r>
+            <a:r>
+              <a:rPr lang="en-US" dirty="0"/>
+              <a:t>:</a:t>
+            </a:r>
+          </a:p>
+          <a:p>
+            <a:pPr lvl="1" algn="just"/>
+            <a:r>
+              <a:rPr lang="en-US" dirty="0" err="1"/>
+              <a:t>normalno</a:t>
+            </a:r>
+            <a:r>
+              <a:rPr lang="en-US" dirty="0"/>
+              <a:t> </a:t>
+            </a:r>
+            <a:r>
+              <a:rPr lang="en-US" dirty="0" err="1"/>
+              <a:t>stanje</a:t>
+            </a:r>
+            <a:r>
+              <a:rPr lang="en-US" dirty="0"/>
+              <a:t> </a:t>
+            </a:r>
+          </a:p>
+          <a:p>
+            <a:pPr lvl="1" algn="just"/>
+            <a:r>
+              <a:rPr lang="en-US" dirty="0" err="1"/>
+              <a:t>pokret</a:t>
+            </a:r>
+            <a:r>
+              <a:rPr lang="en-US" dirty="0"/>
+              <a:t>/</a:t>
+            </a:r>
+            <a:r>
+              <a:rPr lang="en-US" dirty="0" err="1"/>
+              <a:t>događaj</a:t>
+            </a:r>
+            <a:endParaRPr lang="sr-Latn-RS" dirty="0"/>
+          </a:p>
+          <a:p>
+            <a:pPr algn="just"/>
+            <a:r>
+              <a:rPr lang="sr-Latn-RS" dirty="0"/>
+              <a:t>Skripta </a:t>
+            </a:r>
+            <a:r>
+              <a:rPr lang="sr-Latn-RS" b="1" i="1" dirty="0"/>
+              <a:t>procces_data.py </a:t>
+            </a:r>
+            <a:r>
+              <a:rPr lang="sr-Latn-RS" dirty="0"/>
+              <a:t>se koristi da obradi podatke  i pripremi ih za treniranje ML modela. Deli podatke na trening i test skup, kao i podatke na vremenske prozore gde svaki prozor sadrži 4 uzorka. </a:t>
+            </a:r>
+          </a:p>
+          <a:p>
+            <a:pPr algn="just"/>
+            <a:r>
+              <a:rPr lang="sr-Latn-RS" dirty="0"/>
+              <a:t>Skripta </a:t>
+            </a:r>
+            <a:r>
+              <a:rPr lang="sr-Latn-RS" b="1" i="1" dirty="0"/>
+              <a:t>train_model.py </a:t>
+            </a:r>
+            <a:r>
+              <a:rPr lang="sr-Latn-RS" dirty="0"/>
+              <a:t>se koristi za treniranje modela, a </a:t>
+            </a:r>
+            <a:r>
+              <a:rPr lang="sr-Latn-RS" b="1" i="1" dirty="0"/>
+              <a:t>convert_tflite.py </a:t>
+            </a:r>
+            <a:r>
+              <a:rPr lang="sr-Latn-RS" dirty="0"/>
+              <a:t>za konvertovanje model u </a:t>
+            </a:r>
+            <a:r>
+              <a:rPr lang="sr-Latn-RS" dirty="0" err="1"/>
+              <a:t>TensorFlow</a:t>
+            </a:r>
+            <a:r>
+              <a:rPr lang="sr-Latn-RS" dirty="0"/>
+              <a:t> </a:t>
+            </a:r>
+            <a:r>
+              <a:rPr lang="sr-Latn-RS" dirty="0" err="1"/>
+              <a:t>Lite</a:t>
+            </a:r>
+            <a:r>
+              <a:rPr lang="sr-Latn-RS" dirty="0"/>
+              <a:t> format, kako bi mogao da se koristi na </a:t>
+            </a:r>
+            <a:r>
+              <a:rPr lang="sr-Latn-RS" dirty="0" err="1"/>
+              <a:t>Rpi</a:t>
+            </a:r>
+            <a:r>
+              <a:rPr lang="sr-Latn-RS" dirty="0"/>
+              <a:t>. </a:t>
+            </a:r>
+            <a:r>
+              <a:rPr lang="en-US" dirty="0"/>
+              <a:t>Za </a:t>
+            </a:r>
+            <a:r>
+              <a:rPr lang="en-US" dirty="0" err="1"/>
+              <a:t>klasifikaciju</a:t>
+            </a:r>
+            <a:r>
+              <a:rPr lang="en-US" dirty="0"/>
+              <a:t> </a:t>
+            </a:r>
+            <a:r>
+              <a:rPr lang="en-US" dirty="0" err="1"/>
+              <a:t>senzorskih</a:t>
+            </a:r>
+            <a:r>
+              <a:rPr lang="en-US" dirty="0"/>
+              <a:t> </a:t>
+            </a:r>
+            <a:r>
+              <a:rPr lang="en-US" dirty="0" err="1"/>
+              <a:t>podataka</a:t>
+            </a:r>
+            <a:r>
+              <a:rPr lang="en-US" dirty="0"/>
+              <a:t> </a:t>
+            </a:r>
+            <a:r>
+              <a:rPr lang="en-US" dirty="0" err="1"/>
+              <a:t>korišćena</a:t>
+            </a:r>
+            <a:r>
+              <a:rPr lang="en-US" dirty="0"/>
+              <a:t> je 1D </a:t>
+            </a:r>
+            <a:r>
+              <a:rPr lang="en-US" dirty="0" err="1"/>
+              <a:t>konvolutna</a:t>
+            </a:r>
+            <a:r>
+              <a:rPr lang="en-US" dirty="0"/>
+              <a:t> </a:t>
+            </a:r>
+            <a:r>
+              <a:rPr lang="en-US" dirty="0" err="1"/>
+              <a:t>neuronska</a:t>
+            </a:r>
+            <a:r>
+              <a:rPr lang="en-US" dirty="0"/>
+              <a:t> </a:t>
+            </a:r>
+            <a:r>
+              <a:rPr lang="en-US" dirty="0" err="1"/>
+              <a:t>mreža</a:t>
+            </a:r>
+            <a:r>
+              <a:rPr lang="en-US" dirty="0"/>
+              <a:t> (Conv1D), </a:t>
+            </a:r>
+            <a:r>
+              <a:rPr lang="en-US" dirty="0" err="1"/>
+              <a:t>koja</a:t>
+            </a:r>
+            <a:r>
+              <a:rPr lang="en-US" dirty="0"/>
+              <a:t> </a:t>
+            </a:r>
+            <a:r>
+              <a:rPr lang="en-US" dirty="0" err="1"/>
+              <a:t>analizira</a:t>
+            </a:r>
+            <a:r>
+              <a:rPr lang="en-US" dirty="0"/>
+              <a:t> </a:t>
+            </a:r>
+            <a:r>
+              <a:rPr lang="en-US" dirty="0" err="1"/>
+              <a:t>vremenske</a:t>
+            </a:r>
+            <a:r>
+              <a:rPr lang="en-US" dirty="0"/>
+              <a:t> </a:t>
+            </a:r>
+            <a:r>
+              <a:rPr lang="en-US" dirty="0" err="1"/>
+              <a:t>obrasce</a:t>
+            </a:r>
+            <a:r>
+              <a:rPr lang="en-US" dirty="0"/>
+              <a:t> u </a:t>
+            </a:r>
+            <a:r>
+              <a:rPr lang="en-US" dirty="0" err="1"/>
+              <a:t>sekvencama</a:t>
+            </a:r>
+            <a:r>
+              <a:rPr lang="en-US" dirty="0"/>
+              <a:t> </a:t>
+            </a:r>
+            <a:r>
+              <a:rPr lang="en-US" dirty="0" err="1"/>
+              <a:t>podataka</a:t>
+            </a:r>
+            <a:r>
+              <a:rPr lang="en-US" dirty="0"/>
+              <a:t> </a:t>
+            </a:r>
+            <a:r>
+              <a:rPr lang="en-US" dirty="0" err="1"/>
+              <a:t>akcelerometra</a:t>
             </a:r>
             <a:r>
               <a:rPr lang="en-US" dirty="0"/>
               <a:t>.</a:t>
             </a:r>
-            <a:endParaRPr lang="sr-Latn-RS" dirty="0"/>
-          </a:p>
-          <a:p>
-            <a:r>
-              <a:rPr lang="sr-Latn-RS" dirty="0"/>
-              <a:t>Komanda koju je prepoznao model se smatra validnom, ako je verovatnoća klasifikacije </a:t>
-            </a:r>
-            <a:r>
-              <a:rPr lang="sr-Latn-RS" dirty="0" err="1"/>
-              <a:t>value</a:t>
-            </a:r>
-            <a:r>
-              <a:rPr lang="sr-Latn-RS" dirty="0"/>
-              <a:t> &gt; 0.90.</a:t>
-            </a:r>
-            <a:endParaRPr lang="en-US" dirty="0"/>
+            <a:endParaRPr lang="sr-Latn-RS" b="1" i="1" dirty="0"/>
           </a:p>
         </p:txBody>
       </p:sp>
     </p:spTree>
     <p:extLst>
       <p:ext uri="{BB962C8B-B14F-4D97-AF65-F5344CB8AC3E}">
-        <p14:creationId xmlns:p14="http://schemas.microsoft.com/office/powerpoint/2010/main" val="2433535033"/>
+        <p14:creationId xmlns:p14="http://schemas.microsoft.com/office/powerpoint/2010/main" val="2357253622"/>
       </p:ext>
     </p:extLst>
   </p:cSld>
@@ -6298,7 +6024,7 @@
           <a:p>
             <a:r>
               <a:rPr lang="sr-Latn-RS" dirty="0"/>
-              <a:t>Detekcija osvetljenja</a:t>
+              <a:t>Detekcija događaja</a:t>
             </a:r>
             <a:endParaRPr lang="en-US" dirty="0"/>
           </a:p>
@@ -6325,32 +6051,317 @@
           <a:bodyPr/>
           <a:lstStyle/>
           <a:p>
+            <a:pPr algn="just"/>
+            <a:r>
+              <a:rPr lang="en-US" dirty="0"/>
+              <a:t>Servis </a:t>
+            </a:r>
+            <a:r>
+              <a:rPr lang="en-US" b="1" dirty="0"/>
+              <a:t>ml-service</a:t>
+            </a:r>
+            <a:r>
+              <a:rPr lang="en-US" dirty="0"/>
+              <a:t> </a:t>
+            </a:r>
+            <a:r>
+              <a:rPr lang="en-US" dirty="0" err="1"/>
+              <a:t>predstavlja</a:t>
+            </a:r>
+            <a:r>
+              <a:rPr lang="en-US" dirty="0"/>
+              <a:t> </a:t>
+            </a:r>
+            <a:r>
+              <a:rPr lang="en-US" dirty="0" err="1"/>
+              <a:t>komponentu</a:t>
+            </a:r>
+            <a:r>
+              <a:rPr lang="en-US" dirty="0"/>
+              <a:t> </a:t>
+            </a:r>
+            <a:r>
+              <a:rPr lang="en-US" dirty="0" err="1"/>
+              <a:t>zaduženu</a:t>
+            </a:r>
+            <a:r>
+              <a:rPr lang="en-US" dirty="0"/>
+              <a:t> za </a:t>
+            </a:r>
+            <a:r>
+              <a:rPr lang="en-US" dirty="0" err="1"/>
+              <a:t>detekciju</a:t>
+            </a:r>
+            <a:r>
+              <a:rPr lang="en-US" dirty="0"/>
+              <a:t> </a:t>
+            </a:r>
+            <a:r>
+              <a:rPr lang="en-US" dirty="0" err="1"/>
+              <a:t>događaja</a:t>
+            </a:r>
+            <a:r>
+              <a:rPr lang="en-US" dirty="0"/>
+              <a:t> </a:t>
+            </a:r>
+            <a:r>
+              <a:rPr lang="en-US" dirty="0" err="1"/>
+              <a:t>korišćenjem</a:t>
+            </a:r>
+            <a:r>
+              <a:rPr lang="en-US" dirty="0"/>
+              <a:t> </a:t>
+            </a:r>
             <a:r>
               <a:rPr lang="sr-Latn-RS" dirty="0"/>
-              <a:t>Iz RGB vrednosti procenjuje se osvetljenje </a:t>
-            </a:r>
-            <a:r>
-              <a:rPr lang="en-US" dirty="0"/>
-              <a:t>light = (r + g + b) / 3;</a:t>
-            </a:r>
-            <a:endParaRPr lang="sr-Latn-RS" dirty="0"/>
-          </a:p>
-          <a:p>
+              <a:t>istreniranog ML </a:t>
+            </a:r>
+            <a:r>
+              <a:rPr lang="en-US" dirty="0"/>
+              <a:t>model</a:t>
+            </a:r>
             <a:r>
               <a:rPr lang="sr-Latn-RS" dirty="0"/>
-              <a:t>Prag osvetljenja je definisan sa LIGHT_THRESHOLD = 120, pa ako </a:t>
+              <a:t>a</a:t>
+            </a:r>
+            <a:r>
+              <a:rPr lang="en-US" dirty="0"/>
+              <a:t>.</a:t>
+            </a:r>
+          </a:p>
+          <a:p>
+            <a:pPr algn="just"/>
+            <a:r>
+              <a:rPr lang="en-US" dirty="0"/>
+              <a:t>Servis je </a:t>
+            </a:r>
+            <a:r>
+              <a:rPr lang="en-US" dirty="0" err="1"/>
+              <a:t>pretplaćen</a:t>
+            </a:r>
+            <a:r>
+              <a:rPr lang="en-US" dirty="0"/>
+              <a:t> </a:t>
+            </a:r>
+            <a:r>
+              <a:rPr lang="en-US" dirty="0" err="1"/>
+              <a:t>na</a:t>
+            </a:r>
+            <a:r>
+              <a:rPr lang="en-US" dirty="0"/>
+              <a:t> MQTT topic </a:t>
+            </a:r>
+            <a:r>
+              <a:rPr lang="en-US" dirty="0" err="1"/>
+              <a:t>sa</a:t>
+            </a:r>
+            <a:r>
+              <a:rPr lang="en-US" dirty="0"/>
+              <a:t> </a:t>
+            </a:r>
+            <a:r>
+              <a:rPr lang="en-US" dirty="0" err="1"/>
+              <a:t>senzorskim</a:t>
+            </a:r>
+            <a:r>
+              <a:rPr lang="en-US" dirty="0"/>
+              <a:t> </a:t>
+            </a:r>
+            <a:r>
+              <a:rPr lang="en-US" dirty="0" err="1"/>
+              <a:t>podacima</a:t>
+            </a:r>
+            <a:r>
+              <a:rPr lang="en-US" dirty="0"/>
+              <a:t>, </a:t>
+            </a:r>
+            <a:r>
+              <a:rPr lang="en-US" dirty="0" err="1"/>
+              <a:t>formira</a:t>
+            </a:r>
+            <a:r>
+              <a:rPr lang="en-US" dirty="0"/>
+              <a:t> </a:t>
+            </a:r>
+            <a:r>
+              <a:rPr lang="en-US" dirty="0" err="1"/>
+              <a:t>ulazne</a:t>
+            </a:r>
+            <a:r>
+              <a:rPr lang="en-US" dirty="0"/>
+              <a:t> </a:t>
+            </a:r>
+            <a:r>
+              <a:rPr lang="en-US" dirty="0" err="1"/>
+              <a:t>prozore</a:t>
+            </a:r>
+            <a:r>
+              <a:rPr lang="en-US" dirty="0"/>
+              <a:t> </a:t>
+            </a:r>
+            <a:r>
+              <a:rPr lang="en-US" dirty="0" err="1"/>
+              <a:t>odgovarajuće</a:t>
+            </a:r>
+            <a:r>
+              <a:rPr lang="en-US" dirty="0"/>
+              <a:t> </a:t>
+            </a:r>
+            <a:r>
+              <a:rPr lang="en-US" dirty="0" err="1"/>
+              <a:t>veličine</a:t>
+            </a:r>
+            <a:r>
+              <a:rPr lang="en-US" dirty="0"/>
+              <a:t> </a:t>
+            </a:r>
+            <a:r>
+              <a:rPr lang="en-US" dirty="0" err="1"/>
+              <a:t>i</a:t>
+            </a:r>
+            <a:r>
+              <a:rPr lang="en-US" dirty="0"/>
+              <a:t> </a:t>
+            </a:r>
+            <a:r>
+              <a:rPr lang="en-US" dirty="0" err="1"/>
+              <a:t>izvršava</a:t>
+            </a:r>
+            <a:r>
+              <a:rPr lang="en-US" dirty="0"/>
+              <a:t> TensorFlow Lite model </a:t>
+            </a:r>
+            <a:r>
+              <a:rPr lang="en-US" dirty="0" err="1"/>
+              <a:t>na</a:t>
+            </a:r>
+            <a:r>
+              <a:rPr lang="en-US" dirty="0"/>
+              <a:t> Raspberry Pi </a:t>
+            </a:r>
+            <a:r>
+              <a:rPr lang="en-US" dirty="0" err="1"/>
+              <a:t>uređaju</a:t>
+            </a:r>
+            <a:r>
+              <a:rPr lang="en-US" dirty="0"/>
+              <a:t>. Na </a:t>
+            </a:r>
+            <a:r>
+              <a:rPr lang="en-US" dirty="0" err="1"/>
+              <a:t>osnovu</a:t>
+            </a:r>
+            <a:r>
+              <a:rPr lang="en-US" dirty="0"/>
+              <a:t> </a:t>
+            </a:r>
+            <a:r>
+              <a:rPr lang="en-US" dirty="0" err="1"/>
+              <a:t>rezultata</a:t>
+            </a:r>
+            <a:r>
+              <a:rPr lang="en-US" dirty="0"/>
+              <a:t> </a:t>
+            </a:r>
+            <a:r>
+              <a:rPr lang="en-US" dirty="0" err="1"/>
+              <a:t>klasifikacije</a:t>
+            </a:r>
+            <a:r>
+              <a:rPr lang="en-US" dirty="0"/>
+              <a:t> </a:t>
+            </a:r>
+            <a:r>
+              <a:rPr lang="en-US" dirty="0" err="1"/>
+              <a:t>servis</a:t>
+            </a:r>
+            <a:r>
+              <a:rPr lang="en-US" dirty="0"/>
+              <a:t> </a:t>
+            </a:r>
+            <a:r>
+              <a:rPr lang="en-US" dirty="0" err="1"/>
+              <a:t>određuje</a:t>
+            </a:r>
+            <a:r>
+              <a:rPr lang="en-US" dirty="0"/>
+              <a:t> da li je </a:t>
+            </a:r>
+            <a:r>
+              <a:rPr lang="en-US" dirty="0" err="1"/>
+              <a:t>detektovan</a:t>
+            </a:r>
+            <a:r>
+              <a:rPr lang="en-US" dirty="0"/>
+              <a:t> </a:t>
+            </a:r>
+            <a:r>
+              <a:rPr lang="en-US" dirty="0" err="1"/>
+              <a:t>događaj</a:t>
+            </a:r>
+            <a:r>
+              <a:rPr lang="en-US" dirty="0"/>
+              <a:t> </a:t>
+            </a:r>
+            <a:r>
+              <a:rPr lang="en-US" dirty="0" err="1"/>
+              <a:t>i</a:t>
+            </a:r>
+            <a:r>
+              <a:rPr lang="en-US" dirty="0"/>
+              <a:t> u tom </a:t>
+            </a:r>
+            <a:r>
+              <a:rPr lang="en-US" dirty="0" err="1"/>
+              <a:t>slučaju</a:t>
+            </a:r>
+            <a:r>
+              <a:rPr lang="en-US" dirty="0"/>
+              <a:t> </a:t>
+            </a:r>
+            <a:r>
+              <a:rPr lang="en-US" dirty="0" err="1"/>
+              <a:t>objavljuje</a:t>
+            </a:r>
+            <a:r>
+              <a:rPr lang="en-US" dirty="0"/>
+              <a:t> </a:t>
+            </a:r>
+            <a:r>
+              <a:rPr lang="en-US" dirty="0" err="1"/>
+              <a:t>odgovarajuću</a:t>
+            </a:r>
+            <a:r>
+              <a:rPr lang="en-US" dirty="0"/>
+              <a:t> </a:t>
+            </a:r>
+            <a:r>
+              <a:rPr lang="en-US" dirty="0" err="1"/>
+              <a:t>komandu</a:t>
+            </a:r>
+            <a:r>
+              <a:rPr lang="en-US" dirty="0"/>
+              <a:t> </a:t>
+            </a:r>
+            <a:r>
+              <a:rPr lang="en-US" dirty="0" err="1"/>
+              <a:t>na</a:t>
+            </a:r>
+            <a:r>
+              <a:rPr lang="en-US" dirty="0"/>
+              <a:t> MQTT broker.</a:t>
+            </a:r>
+            <a:r>
+              <a:rPr lang="sr-Latn-RS" dirty="0"/>
+              <a:t> Ukoliko je detektovano pomeranje </a:t>
             </a:r>
             <a:r>
               <a:rPr lang="sr-Latn-RS" dirty="0" err="1"/>
-              <a:t>light</a:t>
-            </a:r>
-            <a:r>
-              <a:rPr lang="en-US" dirty="0"/>
-              <a:t>&gt;</a:t>
+              <a:t>Arduina</a:t>
             </a:r>
             <a:r>
               <a:rPr lang="sr-Latn-RS" dirty="0"/>
-              <a:t>120 crvena LED se uključuje.</a:t>
+              <a:t> pali se zelena LED.</a:t>
             </a:r>
             <a:endParaRPr lang="en-US" dirty="0"/>
           </a:p>

</xml_diff>